<commit_message>
Update and add paper figures
</commit_message>
<xml_diff>
--- a/figures/fig1_diagram.pptx
+++ b/figures/fig1_diagram.pptx
@@ -6,6 +6,11 @@
   </p:sldMasterIdLst>
   <p:sldIdLst>
     <p:sldId id="258" r:id="rId2"/>
+    <p:sldId id="264" r:id="rId3"/>
+    <p:sldId id="265" r:id="rId4"/>
+    <p:sldId id="266" r:id="rId5"/>
+    <p:sldId id="267" r:id="rId6"/>
+    <p:sldId id="268" r:id="rId7"/>
   </p:sldIdLst>
   <p:sldSz cx="12192000" cy="6858000"/>
   <p:notesSz cx="6858000" cy="9144000"/>
@@ -259,7 +264,7 @@
           <a:p>
             <a:fld id="{75A9CF98-CC55-774D-9AE2-4D7D2CE05F38}" type="datetimeFigureOut">
               <a:rPr lang="en-US" smtClean="0"/>
-              <a:t>8/20/25</a:t>
+              <a:t>9/1/25</a:t>
             </a:fld>
             <a:endParaRPr lang="en-US"/>
           </a:p>
@@ -457,7 +462,7 @@
           <a:p>
             <a:fld id="{75A9CF98-CC55-774D-9AE2-4D7D2CE05F38}" type="datetimeFigureOut">
               <a:rPr lang="en-US" smtClean="0"/>
-              <a:t>8/20/25</a:t>
+              <a:t>9/1/25</a:t>
             </a:fld>
             <a:endParaRPr lang="en-US"/>
           </a:p>
@@ -665,7 +670,7 @@
           <a:p>
             <a:fld id="{75A9CF98-CC55-774D-9AE2-4D7D2CE05F38}" type="datetimeFigureOut">
               <a:rPr lang="en-US" smtClean="0"/>
-              <a:t>8/20/25</a:t>
+              <a:t>9/1/25</a:t>
             </a:fld>
             <a:endParaRPr lang="en-US"/>
           </a:p>
@@ -863,7 +868,7 @@
           <a:p>
             <a:fld id="{75A9CF98-CC55-774D-9AE2-4D7D2CE05F38}" type="datetimeFigureOut">
               <a:rPr lang="en-US" smtClean="0"/>
-              <a:t>8/20/25</a:t>
+              <a:t>9/1/25</a:t>
             </a:fld>
             <a:endParaRPr lang="en-US"/>
           </a:p>
@@ -1138,7 +1143,7 @@
           <a:p>
             <a:fld id="{75A9CF98-CC55-774D-9AE2-4D7D2CE05F38}" type="datetimeFigureOut">
               <a:rPr lang="en-US" smtClean="0"/>
-              <a:t>8/20/25</a:t>
+              <a:t>9/1/25</a:t>
             </a:fld>
             <a:endParaRPr lang="en-US"/>
           </a:p>
@@ -1403,7 +1408,7 @@
           <a:p>
             <a:fld id="{75A9CF98-CC55-774D-9AE2-4D7D2CE05F38}" type="datetimeFigureOut">
               <a:rPr lang="en-US" smtClean="0"/>
-              <a:t>8/20/25</a:t>
+              <a:t>9/1/25</a:t>
             </a:fld>
             <a:endParaRPr lang="en-US"/>
           </a:p>
@@ -1815,7 +1820,7 @@
           <a:p>
             <a:fld id="{75A9CF98-CC55-774D-9AE2-4D7D2CE05F38}" type="datetimeFigureOut">
               <a:rPr lang="en-US" smtClean="0"/>
-              <a:t>8/20/25</a:t>
+              <a:t>9/1/25</a:t>
             </a:fld>
             <a:endParaRPr lang="en-US"/>
           </a:p>
@@ -1956,7 +1961,7 @@
           <a:p>
             <a:fld id="{75A9CF98-CC55-774D-9AE2-4D7D2CE05F38}" type="datetimeFigureOut">
               <a:rPr lang="en-US" smtClean="0"/>
-              <a:t>8/20/25</a:t>
+              <a:t>9/1/25</a:t>
             </a:fld>
             <a:endParaRPr lang="en-US"/>
           </a:p>
@@ -2069,7 +2074,7 @@
           <a:p>
             <a:fld id="{75A9CF98-CC55-774D-9AE2-4D7D2CE05F38}" type="datetimeFigureOut">
               <a:rPr lang="en-US" smtClean="0"/>
-              <a:t>8/20/25</a:t>
+              <a:t>9/1/25</a:t>
             </a:fld>
             <a:endParaRPr lang="en-US"/>
           </a:p>
@@ -2380,7 +2385,7 @@
           <a:p>
             <a:fld id="{75A9CF98-CC55-774D-9AE2-4D7D2CE05F38}" type="datetimeFigureOut">
               <a:rPr lang="en-US" smtClean="0"/>
-              <a:t>8/20/25</a:t>
+              <a:t>9/1/25</a:t>
             </a:fld>
             <a:endParaRPr lang="en-US"/>
           </a:p>
@@ -2668,7 +2673,7 @@
           <a:p>
             <a:fld id="{75A9CF98-CC55-774D-9AE2-4D7D2CE05F38}" type="datetimeFigureOut">
               <a:rPr lang="en-US" smtClean="0"/>
-              <a:t>8/20/25</a:t>
+              <a:t>9/1/25</a:t>
             </a:fld>
             <a:endParaRPr lang="en-US"/>
           </a:p>
@@ -2909,7 +2914,7 @@
           <a:p>
             <a:fld id="{75A9CF98-CC55-774D-9AE2-4D7D2CE05F38}" type="datetimeFigureOut">
               <a:rPr lang="en-US" smtClean="0"/>
-              <a:t>8/20/25</a:t>
+              <a:t>9/1/25</a:t>
             </a:fld>
             <a:endParaRPr lang="en-US"/>
           </a:p>
@@ -4786,8 +4791,8 @@
             </a:fontRef>
           </p:style>
         </p:cxnSp>
-        <mc:AlternateContent xmlns:mc="http://schemas.openxmlformats.org/markup-compatibility/2006">
-          <mc:Choice xmlns:a14="http://schemas.microsoft.com/office/drawing/2010/main" Requires="a14">
+        <mc:AlternateContent xmlns:mc="http://schemas.openxmlformats.org/markup-compatibility/2006" xmlns:a14="http://schemas.microsoft.com/office/drawing/2010/main">
+          <mc:Choice Requires="a14">
             <p:sp>
               <p:nvSpPr>
                 <p:cNvPr id="20" name="TextBox 35">
@@ -4933,7 +4938,7 @@
               </p:txBody>
             </p:sp>
           </mc:Choice>
-          <mc:Fallback>
+          <mc:Fallback xmlns="">
             <p:sp>
               <p:nvSpPr>
                 <p:cNvPr id="20" name="TextBox 35">
@@ -5124,8 +5129,8 @@
             </a:p>
           </p:txBody>
         </p:sp>
-        <mc:AlternateContent xmlns:mc="http://schemas.openxmlformats.org/markup-compatibility/2006">
-          <mc:Choice xmlns:a14="http://schemas.microsoft.com/office/drawing/2010/main" Requires="a14">
+        <mc:AlternateContent xmlns:mc="http://schemas.openxmlformats.org/markup-compatibility/2006" xmlns:a14="http://schemas.microsoft.com/office/drawing/2010/main">
+          <mc:Choice Requires="a14">
             <p:sp>
               <p:nvSpPr>
                 <p:cNvPr id="53" name="TextBox 35">
@@ -5271,7 +5276,7 @@
               </p:txBody>
             </p:sp>
           </mc:Choice>
-          <mc:Fallback>
+          <mc:Fallback xmlns="">
             <p:sp>
               <p:nvSpPr>
                 <p:cNvPr id="53" name="TextBox 35">
@@ -5360,8 +5365,8 @@
             </a:fontRef>
           </p:style>
         </p:cxnSp>
-        <mc:AlternateContent xmlns:mc="http://schemas.openxmlformats.org/markup-compatibility/2006">
-          <mc:Choice xmlns:a14="http://schemas.microsoft.com/office/drawing/2010/main" Requires="a14">
+        <mc:AlternateContent xmlns:mc="http://schemas.openxmlformats.org/markup-compatibility/2006" xmlns:a14="http://schemas.microsoft.com/office/drawing/2010/main">
+          <mc:Choice Requires="a14">
             <p:sp>
               <p:nvSpPr>
                 <p:cNvPr id="56" name="TextBox 35">
@@ -5507,7 +5512,7 @@
               </p:txBody>
             </p:sp>
           </mc:Choice>
-          <mc:Fallback>
+          <mc:Fallback xmlns="">
             <p:sp>
               <p:nvSpPr>
                 <p:cNvPr id="56" name="TextBox 35">
@@ -5850,8 +5855,8 @@
             </a:p>
           </p:txBody>
         </p:sp>
-        <mc:AlternateContent xmlns:mc="http://schemas.openxmlformats.org/markup-compatibility/2006">
-          <mc:Choice xmlns:a14="http://schemas.microsoft.com/office/drawing/2010/main" Requires="a14">
+        <mc:AlternateContent xmlns:mc="http://schemas.openxmlformats.org/markup-compatibility/2006" xmlns:a14="http://schemas.microsoft.com/office/drawing/2010/main">
+          <mc:Choice Requires="a14">
             <p:sp>
               <p:nvSpPr>
                 <p:cNvPr id="76" name="TextBox 35">
@@ -6015,7 +6020,7 @@
               </p:txBody>
             </p:sp>
           </mc:Choice>
-          <mc:Fallback>
+          <mc:Fallback xmlns="">
             <p:sp>
               <p:nvSpPr>
                 <p:cNvPr id="76" name="TextBox 35">
@@ -6060,8 +6065,8 @@
             </p:sp>
           </mc:Fallback>
         </mc:AlternateContent>
-        <mc:AlternateContent xmlns:mc="http://schemas.openxmlformats.org/markup-compatibility/2006">
-          <mc:Choice xmlns:a14="http://schemas.microsoft.com/office/drawing/2010/main" Requires="a14">
+        <mc:AlternateContent xmlns:mc="http://schemas.openxmlformats.org/markup-compatibility/2006" xmlns:a14="http://schemas.microsoft.com/office/drawing/2010/main">
+          <mc:Choice Requires="a14">
             <p:sp>
               <p:nvSpPr>
                 <p:cNvPr id="77" name="TextBox 35">
@@ -6313,7 +6318,7 @@
               </p:txBody>
             </p:sp>
           </mc:Choice>
-          <mc:Fallback>
+          <mc:Fallback xmlns="">
             <p:sp>
               <p:nvSpPr>
                 <p:cNvPr id="77" name="TextBox 35">
@@ -6428,8 +6433,8 @@
             </a:p>
           </p:txBody>
         </p:sp>
-        <mc:AlternateContent xmlns:mc="http://schemas.openxmlformats.org/markup-compatibility/2006">
-          <mc:Choice xmlns:a14="http://schemas.microsoft.com/office/drawing/2010/main" Requires="a14">
+        <mc:AlternateContent xmlns:mc="http://schemas.openxmlformats.org/markup-compatibility/2006" xmlns:a14="http://schemas.microsoft.com/office/drawing/2010/main">
+          <mc:Choice Requires="a14">
             <p:sp>
               <p:nvSpPr>
                 <p:cNvPr id="14" name="TextBox 35">
@@ -6745,7 +6750,7 @@
               </p:txBody>
             </p:sp>
           </mc:Choice>
-          <mc:Fallback>
+          <mc:Fallback xmlns="">
             <p:sp>
               <p:nvSpPr>
                 <p:cNvPr id="14" name="TextBox 35">
@@ -6889,6 +6894,2571 @@
     <p:extLst>
       <p:ext uri="{BB962C8B-B14F-4D97-AF65-F5344CB8AC3E}">
         <p14:creationId xmlns:p14="http://schemas.microsoft.com/office/powerpoint/2010/main" val="3319264901"/>
+      </p:ext>
+    </p:extLst>
+  </p:cSld>
+  <p:clrMapOvr>
+    <a:masterClrMapping/>
+  </p:clrMapOvr>
+</p:sld>
+</file>
+
+<file path=ppt/slides/slide2.xml><?xml version="1.0" encoding="utf-8"?>
+<p:sld xmlns:a="http://schemas.openxmlformats.org/drawingml/2006/main" xmlns:r="http://schemas.openxmlformats.org/officeDocument/2006/relationships" xmlns:p="http://schemas.openxmlformats.org/presentationml/2006/main">
+  <p:cSld>
+    <p:spTree>
+      <p:nvGrpSpPr>
+        <p:cNvPr id="1" name="">
+          <a:extLst>
+            <a:ext uri="{FF2B5EF4-FFF2-40B4-BE49-F238E27FC236}">
+              <a16:creationId xmlns:a16="http://schemas.microsoft.com/office/drawing/2014/main" id="{F269C566-30FB-C5E0-1004-2C3929CB867C}"/>
+            </a:ext>
+          </a:extLst>
+        </p:cNvPr>
+        <p:cNvGrpSpPr/>
+        <p:nvPr/>
+      </p:nvGrpSpPr>
+      <p:grpSpPr>
+        <a:xfrm>
+          <a:off x="0" y="0"/>
+          <a:ext cx="0" cy="0"/>
+          <a:chOff x="0" y="0"/>
+          <a:chExt cx="0" cy="0"/>
+        </a:xfrm>
+      </p:grpSpPr>
+      <p:sp>
+        <p:nvSpPr>
+          <p:cNvPr id="16" name="TextBox 15">
+            <a:extLst>
+              <a:ext uri="{FF2B5EF4-FFF2-40B4-BE49-F238E27FC236}">
+                <a16:creationId xmlns:a16="http://schemas.microsoft.com/office/drawing/2014/main" id="{B01BEE00-70EF-A39D-2975-6C6AB8379312}"/>
+              </a:ext>
+            </a:extLst>
+          </p:cNvPr>
+          <p:cNvSpPr txBox="1"/>
+          <p:nvPr/>
+        </p:nvSpPr>
+        <p:spPr>
+          <a:xfrm>
+            <a:off x="298724" y="303817"/>
+            <a:ext cx="2259479" cy="369332"/>
+          </a:xfrm>
+          <a:prstGeom prst="rect">
+            <a:avLst/>
+          </a:prstGeom>
+          <a:noFill/>
+        </p:spPr>
+        <p:txBody>
+          <a:bodyPr wrap="square" rtlCol="0">
+            <a:spAutoFit/>
+          </a:bodyPr>
+          <a:lstStyle/>
+          <a:p>
+            <a:r>
+              <a:rPr lang="en-US" b="1" dirty="0">
+                <a:latin typeface="Aptos" panose="020B0004020202020204" pitchFamily="34" charset="0"/>
+              </a:rPr>
+              <a:t>a) </a:t>
+            </a:r>
+            <a:r>
+              <a:rPr lang="en-US" dirty="0">
+                <a:latin typeface="Aptos" panose="020B0004020202020204" pitchFamily="34" charset="0"/>
+              </a:rPr>
+              <a:t>80min</a:t>
+            </a:r>
+            <a:endParaRPr lang="en-US" dirty="0">
+              <a:solidFill>
+                <a:schemeClr val="tx1"/>
+              </a:solidFill>
+              <a:latin typeface="Aptos" panose="020B0004020202020204" pitchFamily="34" charset="0"/>
+            </a:endParaRPr>
+          </a:p>
+        </p:txBody>
+      </p:sp>
+      <p:pic>
+        <p:nvPicPr>
+          <p:cNvPr id="34" name="Picture 33">
+            <a:extLst>
+              <a:ext uri="{FF2B5EF4-FFF2-40B4-BE49-F238E27FC236}">
+                <a16:creationId xmlns:a16="http://schemas.microsoft.com/office/drawing/2014/main" id="{B147E5E7-98C2-EFF8-7F50-D62F1A059E22}"/>
+              </a:ext>
+            </a:extLst>
+          </p:cNvPr>
+          <p:cNvPicPr>
+            <a:picLocks noChangeAspect="1"/>
+          </p:cNvPicPr>
+          <p:nvPr/>
+        </p:nvPicPr>
+        <p:blipFill>
+          <a:blip r:embed="rId2"/>
+          <a:srcRect l="22911" t="10494" r="17774" b="6296"/>
+          <a:stretch>
+            <a:fillRect/>
+          </a:stretch>
+        </p:blipFill>
+        <p:spPr>
+          <a:xfrm>
+            <a:off x="103375" y="826696"/>
+            <a:ext cx="2665945" cy="3549940"/>
+          </a:xfrm>
+          <a:prstGeom prst="rect">
+            <a:avLst/>
+          </a:prstGeom>
+        </p:spPr>
+      </p:pic>
+      <p:pic>
+        <p:nvPicPr>
+          <p:cNvPr id="40" name="Picture 39">
+            <a:extLst>
+              <a:ext uri="{FF2B5EF4-FFF2-40B4-BE49-F238E27FC236}">
+                <a16:creationId xmlns:a16="http://schemas.microsoft.com/office/drawing/2014/main" id="{4C8D3FB2-FF0F-9AC6-D560-8197FAAAEC4E}"/>
+              </a:ext>
+            </a:extLst>
+          </p:cNvPr>
+          <p:cNvPicPr>
+            <a:picLocks noChangeAspect="1"/>
+          </p:cNvPicPr>
+          <p:nvPr/>
+        </p:nvPicPr>
+        <p:blipFill>
+          <a:blip r:embed="rId3"/>
+          <a:srcRect l="21814" t="11509" r="18870" b="5404"/>
+          <a:stretch>
+            <a:fillRect/>
+          </a:stretch>
+        </p:blipFill>
+        <p:spPr>
+          <a:xfrm>
+            <a:off x="2769320" y="826696"/>
+            <a:ext cx="2669865" cy="3549940"/>
+          </a:xfrm>
+          <a:prstGeom prst="rect">
+            <a:avLst/>
+          </a:prstGeom>
+        </p:spPr>
+      </p:pic>
+      <p:pic>
+        <p:nvPicPr>
+          <p:cNvPr id="42" name="Picture 41">
+            <a:extLst>
+              <a:ext uri="{FF2B5EF4-FFF2-40B4-BE49-F238E27FC236}">
+                <a16:creationId xmlns:a16="http://schemas.microsoft.com/office/drawing/2014/main" id="{8FCE5C16-FB0A-522B-34EA-3F261378EFEE}"/>
+              </a:ext>
+            </a:extLst>
+          </p:cNvPr>
+          <p:cNvPicPr>
+            <a:picLocks noChangeAspect="1"/>
+          </p:cNvPicPr>
+          <p:nvPr/>
+        </p:nvPicPr>
+        <p:blipFill>
+          <a:blip r:embed="rId4"/>
+          <a:srcRect l="21814" t="11930" r="18870" b="5123"/>
+          <a:stretch>
+            <a:fillRect/>
+          </a:stretch>
+        </p:blipFill>
+        <p:spPr>
+          <a:xfrm>
+            <a:off x="5603276" y="826696"/>
+            <a:ext cx="2674383" cy="3549941"/>
+          </a:xfrm>
+          <a:prstGeom prst="rect">
+            <a:avLst/>
+          </a:prstGeom>
+        </p:spPr>
+      </p:pic>
+      <p:sp>
+        <p:nvSpPr>
+          <p:cNvPr id="43" name="TextBox 42">
+            <a:extLst>
+              <a:ext uri="{FF2B5EF4-FFF2-40B4-BE49-F238E27FC236}">
+                <a16:creationId xmlns:a16="http://schemas.microsoft.com/office/drawing/2014/main" id="{E41D20DC-4C0A-FBC7-C334-5E59503B54AA}"/>
+              </a:ext>
+            </a:extLst>
+          </p:cNvPr>
+          <p:cNvSpPr txBox="1"/>
+          <p:nvPr/>
+        </p:nvSpPr>
+        <p:spPr>
+          <a:xfrm>
+            <a:off x="2648774" y="303817"/>
+            <a:ext cx="2259479" cy="369332"/>
+          </a:xfrm>
+          <a:prstGeom prst="rect">
+            <a:avLst/>
+          </a:prstGeom>
+          <a:noFill/>
+        </p:spPr>
+        <p:txBody>
+          <a:bodyPr wrap="square" rtlCol="0">
+            <a:spAutoFit/>
+          </a:bodyPr>
+          <a:lstStyle/>
+          <a:p>
+            <a:r>
+              <a:rPr lang="en-US" b="1" dirty="0">
+                <a:latin typeface="Aptos" panose="020B0004020202020204" pitchFamily="34" charset="0"/>
+              </a:rPr>
+              <a:t>b) </a:t>
+            </a:r>
+            <a:r>
+              <a:rPr lang="en-US" dirty="0">
+                <a:latin typeface="Aptos" panose="020B0004020202020204" pitchFamily="34" charset="0"/>
+              </a:rPr>
+              <a:t>1.5h*</a:t>
+            </a:r>
+          </a:p>
+        </p:txBody>
+      </p:sp>
+      <p:sp>
+        <p:nvSpPr>
+          <p:cNvPr id="44" name="TextBox 43">
+            <a:extLst>
+              <a:ext uri="{FF2B5EF4-FFF2-40B4-BE49-F238E27FC236}">
+                <a16:creationId xmlns:a16="http://schemas.microsoft.com/office/drawing/2014/main" id="{C194BB7B-3CD1-C566-D69D-5874EE42D86B}"/>
+              </a:ext>
+            </a:extLst>
+          </p:cNvPr>
+          <p:cNvSpPr txBox="1"/>
+          <p:nvPr/>
+        </p:nvSpPr>
+        <p:spPr>
+          <a:xfrm>
+            <a:off x="4839231" y="328535"/>
+            <a:ext cx="2259479" cy="369332"/>
+          </a:xfrm>
+          <a:prstGeom prst="rect">
+            <a:avLst/>
+          </a:prstGeom>
+          <a:noFill/>
+        </p:spPr>
+        <p:txBody>
+          <a:bodyPr wrap="square" rtlCol="0">
+            <a:spAutoFit/>
+          </a:bodyPr>
+          <a:lstStyle/>
+          <a:p>
+            <a:pPr algn="ctr"/>
+            <a:r>
+              <a:rPr lang="en-US" b="1" dirty="0">
+                <a:latin typeface="Aptos" panose="020B0004020202020204" pitchFamily="34" charset="0"/>
+              </a:rPr>
+              <a:t>c) </a:t>
+            </a:r>
+            <a:r>
+              <a:rPr lang="en-US" dirty="0">
+                <a:latin typeface="Aptos" panose="020B0004020202020204" pitchFamily="34" charset="0"/>
+              </a:rPr>
+              <a:t>2h</a:t>
+            </a:r>
+            <a:endParaRPr lang="en-US" dirty="0">
+              <a:solidFill>
+                <a:schemeClr val="tx1"/>
+              </a:solidFill>
+              <a:latin typeface="Aptos" panose="020B0004020202020204" pitchFamily="34" charset="0"/>
+            </a:endParaRPr>
+          </a:p>
+        </p:txBody>
+      </p:sp>
+      <p:sp>
+        <p:nvSpPr>
+          <p:cNvPr id="45" name="TextBox 44">
+            <a:extLst>
+              <a:ext uri="{FF2B5EF4-FFF2-40B4-BE49-F238E27FC236}">
+                <a16:creationId xmlns:a16="http://schemas.microsoft.com/office/drawing/2014/main" id="{C01EA530-737D-1D06-CB07-44BA23DA9B4E}"/>
+              </a:ext>
+            </a:extLst>
+          </p:cNvPr>
+          <p:cNvSpPr txBox="1"/>
+          <p:nvPr/>
+        </p:nvSpPr>
+        <p:spPr>
+          <a:xfrm>
+            <a:off x="7891603" y="303817"/>
+            <a:ext cx="2259479" cy="369332"/>
+          </a:xfrm>
+          <a:prstGeom prst="rect">
+            <a:avLst/>
+          </a:prstGeom>
+          <a:noFill/>
+        </p:spPr>
+        <p:txBody>
+          <a:bodyPr wrap="square" rtlCol="0">
+            <a:spAutoFit/>
+          </a:bodyPr>
+          <a:lstStyle/>
+          <a:p>
+            <a:pPr algn="ctr"/>
+            <a:r>
+              <a:rPr lang="en-US" b="1" dirty="0">
+                <a:latin typeface="Aptos" panose="020B0004020202020204" pitchFamily="34" charset="0"/>
+              </a:rPr>
+              <a:t>d) </a:t>
+            </a:r>
+            <a:r>
+              <a:rPr lang="en-US" dirty="0">
+                <a:latin typeface="Aptos" panose="020B0004020202020204" pitchFamily="34" charset="0"/>
+              </a:rPr>
+              <a:t>RICO: 20h</a:t>
+            </a:r>
+            <a:endParaRPr lang="en-US" dirty="0">
+              <a:solidFill>
+                <a:schemeClr val="tx1"/>
+              </a:solidFill>
+              <a:latin typeface="Aptos" panose="020B0004020202020204" pitchFamily="34" charset="0"/>
+            </a:endParaRPr>
+          </a:p>
+        </p:txBody>
+      </p:sp>
+      <p:pic>
+        <p:nvPicPr>
+          <p:cNvPr id="47" name="Picture 46">
+            <a:extLst>
+              <a:ext uri="{FF2B5EF4-FFF2-40B4-BE49-F238E27FC236}">
+                <a16:creationId xmlns:a16="http://schemas.microsoft.com/office/drawing/2014/main" id="{61AF4A96-A5D3-BABE-E483-17CB720D1C78}"/>
+              </a:ext>
+            </a:extLst>
+          </p:cNvPr>
+          <p:cNvPicPr>
+            <a:picLocks noChangeAspect="1"/>
+          </p:cNvPicPr>
+          <p:nvPr/>
+        </p:nvPicPr>
+        <p:blipFill>
+          <a:blip r:embed="rId5"/>
+          <a:srcRect l="12904" t="31733" r="3854" b="26597"/>
+          <a:stretch>
+            <a:fillRect/>
+          </a:stretch>
+        </p:blipFill>
+        <p:spPr>
+          <a:xfrm>
+            <a:off x="8334008" y="826696"/>
+            <a:ext cx="3880056" cy="1843690"/>
+          </a:xfrm>
+          <a:prstGeom prst="rect">
+            <a:avLst/>
+          </a:prstGeom>
+        </p:spPr>
+      </p:pic>
+      <p:pic>
+        <p:nvPicPr>
+          <p:cNvPr id="49" name="Picture 48">
+            <a:extLst>
+              <a:ext uri="{FF2B5EF4-FFF2-40B4-BE49-F238E27FC236}">
+                <a16:creationId xmlns:a16="http://schemas.microsoft.com/office/drawing/2014/main" id="{0FFDDE2D-7227-1EDF-2E56-EA1CB4847720}"/>
+              </a:ext>
+            </a:extLst>
+          </p:cNvPr>
+          <p:cNvPicPr>
+            <a:picLocks noChangeAspect="1"/>
+          </p:cNvPicPr>
+          <p:nvPr/>
+        </p:nvPicPr>
+        <p:blipFill>
+          <a:blip r:embed="rId6"/>
+          <a:stretch>
+            <a:fillRect/>
+          </a:stretch>
+        </p:blipFill>
+        <p:spPr>
+          <a:xfrm>
+            <a:off x="0" y="4346029"/>
+            <a:ext cx="2558203" cy="2558203"/>
+          </a:xfrm>
+          <a:prstGeom prst="rect">
+            <a:avLst/>
+          </a:prstGeom>
+        </p:spPr>
+      </p:pic>
+      <p:pic>
+        <p:nvPicPr>
+          <p:cNvPr id="51" name="Picture 50">
+            <a:extLst>
+              <a:ext uri="{FF2B5EF4-FFF2-40B4-BE49-F238E27FC236}">
+                <a16:creationId xmlns:a16="http://schemas.microsoft.com/office/drawing/2014/main" id="{CACA0E46-754D-2EB0-1586-363797A2BF7E}"/>
+              </a:ext>
+            </a:extLst>
+          </p:cNvPr>
+          <p:cNvPicPr>
+            <a:picLocks noChangeAspect="1"/>
+          </p:cNvPicPr>
+          <p:nvPr/>
+        </p:nvPicPr>
+        <p:blipFill>
+          <a:blip r:embed="rId7"/>
+          <a:stretch>
+            <a:fillRect/>
+          </a:stretch>
+        </p:blipFill>
+        <p:spPr>
+          <a:xfrm>
+            <a:off x="2665945" y="4361333"/>
+            <a:ext cx="2558203" cy="2558203"/>
+          </a:xfrm>
+          <a:prstGeom prst="rect">
+            <a:avLst/>
+          </a:prstGeom>
+        </p:spPr>
+      </p:pic>
+      <p:pic>
+        <p:nvPicPr>
+          <p:cNvPr id="53" name="Picture 52">
+            <a:extLst>
+              <a:ext uri="{FF2B5EF4-FFF2-40B4-BE49-F238E27FC236}">
+                <a16:creationId xmlns:a16="http://schemas.microsoft.com/office/drawing/2014/main" id="{ABC0C8EF-0F97-1D37-DFC6-1C731D2F8223}"/>
+              </a:ext>
+            </a:extLst>
+          </p:cNvPr>
+          <p:cNvPicPr>
+            <a:picLocks noChangeAspect="1"/>
+          </p:cNvPicPr>
+          <p:nvPr/>
+        </p:nvPicPr>
+        <p:blipFill>
+          <a:blip r:embed="rId8"/>
+          <a:stretch>
+            <a:fillRect/>
+          </a:stretch>
+        </p:blipFill>
+        <p:spPr>
+          <a:xfrm>
+            <a:off x="8441750" y="4315421"/>
+            <a:ext cx="2558203" cy="2558203"/>
+          </a:xfrm>
+          <a:prstGeom prst="rect">
+            <a:avLst/>
+          </a:prstGeom>
+        </p:spPr>
+      </p:pic>
+      <p:pic>
+        <p:nvPicPr>
+          <p:cNvPr id="55" name="Picture 54">
+            <a:extLst>
+              <a:ext uri="{FF2B5EF4-FFF2-40B4-BE49-F238E27FC236}">
+                <a16:creationId xmlns:a16="http://schemas.microsoft.com/office/drawing/2014/main" id="{A65EDE24-CF53-6C60-393D-2B5F180D8765}"/>
+              </a:ext>
+            </a:extLst>
+          </p:cNvPr>
+          <p:cNvPicPr>
+            <a:picLocks noChangeAspect="1"/>
+          </p:cNvPicPr>
+          <p:nvPr/>
+        </p:nvPicPr>
+        <p:blipFill>
+          <a:blip r:embed="rId9"/>
+          <a:stretch>
+            <a:fillRect/>
+          </a:stretch>
+        </p:blipFill>
+        <p:spPr>
+          <a:xfrm>
+            <a:off x="5542560" y="4315421"/>
+            <a:ext cx="2558203" cy="2558203"/>
+          </a:xfrm>
+          <a:prstGeom prst="rect">
+            <a:avLst/>
+          </a:prstGeom>
+        </p:spPr>
+      </p:pic>
+      <p:cxnSp>
+        <p:nvCxnSpPr>
+          <p:cNvPr id="57" name="Straight Connector 56">
+            <a:extLst>
+              <a:ext uri="{FF2B5EF4-FFF2-40B4-BE49-F238E27FC236}">
+                <a16:creationId xmlns:a16="http://schemas.microsoft.com/office/drawing/2014/main" id="{600E3752-23D7-5496-A15A-6EDE87B96A43}"/>
+              </a:ext>
+            </a:extLst>
+          </p:cNvPr>
+          <p:cNvCxnSpPr>
+            <a:cxnSpLocks/>
+          </p:cNvCxnSpPr>
+          <p:nvPr/>
+        </p:nvCxnSpPr>
+        <p:spPr>
+          <a:xfrm>
+            <a:off x="8277659" y="826696"/>
+            <a:ext cx="0" cy="5910988"/>
+          </a:xfrm>
+          <a:prstGeom prst="line">
+            <a:avLst/>
+          </a:prstGeom>
+          <a:ln>
+            <a:solidFill>
+              <a:schemeClr val="tx1">
+                <a:lumMod val="50000"/>
+                <a:lumOff val="50000"/>
+              </a:schemeClr>
+            </a:solidFill>
+            <a:prstDash val="solid"/>
+          </a:ln>
+        </p:spPr>
+        <p:style>
+          <a:lnRef idx="2">
+            <a:schemeClr val="accent1"/>
+          </a:lnRef>
+          <a:fillRef idx="0">
+            <a:schemeClr val="accent1"/>
+          </a:fillRef>
+          <a:effectRef idx="1">
+            <a:schemeClr val="accent1"/>
+          </a:effectRef>
+          <a:fontRef idx="minor">
+            <a:schemeClr val="tx1"/>
+          </a:fontRef>
+        </p:style>
+      </p:cxnSp>
+    </p:spTree>
+    <p:extLst>
+      <p:ext uri="{BB962C8B-B14F-4D97-AF65-F5344CB8AC3E}">
+        <p14:creationId xmlns:p14="http://schemas.microsoft.com/office/powerpoint/2010/main" val="3124289402"/>
+      </p:ext>
+    </p:extLst>
+  </p:cSld>
+  <p:clrMapOvr>
+    <a:masterClrMapping/>
+  </p:clrMapOvr>
+</p:sld>
+</file>
+
+<file path=ppt/slides/slide3.xml><?xml version="1.0" encoding="utf-8"?>
+<p:sld xmlns:a="http://schemas.openxmlformats.org/drawingml/2006/main" xmlns:r="http://schemas.openxmlformats.org/officeDocument/2006/relationships" xmlns:p="http://schemas.openxmlformats.org/presentationml/2006/main">
+  <p:cSld>
+    <p:spTree>
+      <p:nvGrpSpPr>
+        <p:cNvPr id="1" name=""/>
+        <p:cNvGrpSpPr/>
+        <p:nvPr/>
+      </p:nvGrpSpPr>
+      <p:grpSpPr>
+        <a:xfrm>
+          <a:off x="0" y="0"/>
+          <a:ext cx="0" cy="0"/>
+          <a:chOff x="0" y="0"/>
+          <a:chExt cx="0" cy="0"/>
+        </a:xfrm>
+      </p:grpSpPr>
+      <p:pic>
+        <p:nvPicPr>
+          <p:cNvPr id="13" name="Picture 12">
+            <a:extLst>
+              <a:ext uri="{FF2B5EF4-FFF2-40B4-BE49-F238E27FC236}">
+                <a16:creationId xmlns:a16="http://schemas.microsoft.com/office/drawing/2014/main" id="{3716017B-CF74-6DC9-C8E0-FBDC21E6C932}"/>
+              </a:ext>
+            </a:extLst>
+          </p:cNvPr>
+          <p:cNvPicPr>
+            <a:picLocks noChangeAspect="1"/>
+          </p:cNvPicPr>
+          <p:nvPr/>
+        </p:nvPicPr>
+        <p:blipFill>
+          <a:blip r:embed="rId2"/>
+          <a:srcRect l="1972" r="26536"/>
+          <a:stretch>
+            <a:fillRect/>
+          </a:stretch>
+        </p:blipFill>
+        <p:spPr>
+          <a:xfrm>
+            <a:off x="306042" y="1907252"/>
+            <a:ext cx="3438968" cy="3610329"/>
+          </a:xfrm>
+          <a:prstGeom prst="rect">
+            <a:avLst/>
+          </a:prstGeom>
+        </p:spPr>
+      </p:pic>
+      <p:pic>
+        <p:nvPicPr>
+          <p:cNvPr id="15" name="Picture 14">
+            <a:extLst>
+              <a:ext uri="{FF2B5EF4-FFF2-40B4-BE49-F238E27FC236}">
+                <a16:creationId xmlns:a16="http://schemas.microsoft.com/office/drawing/2014/main" id="{4422557D-440D-7C4A-127F-99CF8FA8CB29}"/>
+              </a:ext>
+            </a:extLst>
+          </p:cNvPr>
+          <p:cNvPicPr>
+            <a:picLocks noChangeAspect="1"/>
+          </p:cNvPicPr>
+          <p:nvPr/>
+        </p:nvPicPr>
+        <p:blipFill>
+          <a:blip r:embed="rId3"/>
+          <a:srcRect l="2193" r="24776"/>
+          <a:stretch>
+            <a:fillRect/>
+          </a:stretch>
+        </p:blipFill>
+        <p:spPr>
+          <a:xfrm>
+            <a:off x="3745010" y="1842268"/>
+            <a:ext cx="3576270" cy="3675313"/>
+          </a:xfrm>
+          <a:prstGeom prst="rect">
+            <a:avLst/>
+          </a:prstGeom>
+        </p:spPr>
+      </p:pic>
+      <p:pic>
+        <p:nvPicPr>
+          <p:cNvPr id="17" name="Picture 16">
+            <a:extLst>
+              <a:ext uri="{FF2B5EF4-FFF2-40B4-BE49-F238E27FC236}">
+                <a16:creationId xmlns:a16="http://schemas.microsoft.com/office/drawing/2014/main" id="{9C2722EB-82CC-99AE-B645-39EB95BABF92}"/>
+              </a:ext>
+            </a:extLst>
+          </p:cNvPr>
+          <p:cNvPicPr>
+            <a:picLocks noChangeAspect="1"/>
+          </p:cNvPicPr>
+          <p:nvPr/>
+        </p:nvPicPr>
+        <p:blipFill>
+          <a:blip r:embed="rId4"/>
+          <a:srcRect l="8791"/>
+          <a:stretch>
+            <a:fillRect/>
+          </a:stretch>
+        </p:blipFill>
+        <p:spPr>
+          <a:xfrm>
+            <a:off x="7321280" y="1842268"/>
+            <a:ext cx="4387403" cy="3610329"/>
+          </a:xfrm>
+          <a:prstGeom prst="rect">
+            <a:avLst/>
+          </a:prstGeom>
+        </p:spPr>
+      </p:pic>
+      <p:sp>
+        <p:nvSpPr>
+          <p:cNvPr id="18" name="TextBox 17">
+            <a:extLst>
+              <a:ext uri="{FF2B5EF4-FFF2-40B4-BE49-F238E27FC236}">
+                <a16:creationId xmlns:a16="http://schemas.microsoft.com/office/drawing/2014/main" id="{D826E07D-A6DA-40ED-F1D5-A488DAFA13CE}"/>
+              </a:ext>
+            </a:extLst>
+          </p:cNvPr>
+          <p:cNvSpPr txBox="1"/>
+          <p:nvPr/>
+        </p:nvSpPr>
+        <p:spPr>
+          <a:xfrm>
+            <a:off x="-233953" y="1983522"/>
+            <a:ext cx="2259479" cy="369332"/>
+          </a:xfrm>
+          <a:prstGeom prst="rect">
+            <a:avLst/>
+          </a:prstGeom>
+          <a:noFill/>
+        </p:spPr>
+        <p:txBody>
+          <a:bodyPr wrap="square" rtlCol="0">
+            <a:spAutoFit/>
+          </a:bodyPr>
+          <a:lstStyle/>
+          <a:p>
+            <a:pPr algn="ctr"/>
+            <a:r>
+              <a:rPr lang="en-US" b="1" dirty="0">
+                <a:latin typeface="Aptos" panose="020B0004020202020204" pitchFamily="34" charset="0"/>
+              </a:rPr>
+              <a:t>a)</a:t>
+            </a:r>
+            <a:r>
+              <a:rPr lang="en-US" b="1" dirty="0">
+                <a:solidFill>
+                  <a:schemeClr val="tx1"/>
+                </a:solidFill>
+                <a:latin typeface="Aptos" panose="020B0004020202020204" pitchFamily="34" charset="0"/>
+              </a:rPr>
+              <a:t> </a:t>
+            </a:r>
+            <a:r>
+              <a:rPr lang="en-US" b="1" dirty="0" err="1">
+                <a:solidFill>
+                  <a:schemeClr val="tx1"/>
+                </a:solidFill>
+                <a:latin typeface="Aptos" panose="020B0004020202020204" pitchFamily="34" charset="0"/>
+              </a:rPr>
+              <a:t>SINDy</a:t>
+            </a:r>
+            <a:endParaRPr lang="en-US" b="1" dirty="0">
+              <a:solidFill>
+                <a:schemeClr val="tx1"/>
+              </a:solidFill>
+              <a:latin typeface="Aptos" panose="020B0004020202020204" pitchFamily="34" charset="0"/>
+            </a:endParaRPr>
+          </a:p>
+        </p:txBody>
+      </p:sp>
+      <p:sp>
+        <p:nvSpPr>
+          <p:cNvPr id="19" name="TextBox 18">
+            <a:extLst>
+              <a:ext uri="{FF2B5EF4-FFF2-40B4-BE49-F238E27FC236}">
+                <a16:creationId xmlns:a16="http://schemas.microsoft.com/office/drawing/2014/main" id="{E9548505-F0F3-312D-F32C-413928F824FB}"/>
+              </a:ext>
+            </a:extLst>
+          </p:cNvPr>
+          <p:cNvSpPr txBox="1"/>
+          <p:nvPr/>
+        </p:nvSpPr>
+        <p:spPr>
+          <a:xfrm>
+            <a:off x="3548031" y="1968080"/>
+            <a:ext cx="2259479" cy="369332"/>
+          </a:xfrm>
+          <a:prstGeom prst="rect">
+            <a:avLst/>
+          </a:prstGeom>
+          <a:noFill/>
+        </p:spPr>
+        <p:txBody>
+          <a:bodyPr wrap="square" rtlCol="0">
+            <a:spAutoFit/>
+          </a:bodyPr>
+          <a:lstStyle/>
+          <a:p>
+            <a:pPr algn="ctr"/>
+            <a:r>
+              <a:rPr lang="en-US" b="1" dirty="0">
+                <a:latin typeface="Aptos" panose="020B0004020202020204" pitchFamily="34" charset="0"/>
+              </a:rPr>
+              <a:t>b)</a:t>
+            </a:r>
+            <a:r>
+              <a:rPr lang="en-US" b="1" dirty="0">
+                <a:solidFill>
+                  <a:schemeClr val="tx1"/>
+                </a:solidFill>
+                <a:latin typeface="Aptos" panose="020B0004020202020204" pitchFamily="34" charset="0"/>
+              </a:rPr>
+              <a:t> NN-driven</a:t>
+            </a:r>
+          </a:p>
+        </p:txBody>
+      </p:sp>
+      <p:sp>
+        <p:nvSpPr>
+          <p:cNvPr id="20" name="TextBox 19">
+            <a:extLst>
+              <a:ext uri="{FF2B5EF4-FFF2-40B4-BE49-F238E27FC236}">
+                <a16:creationId xmlns:a16="http://schemas.microsoft.com/office/drawing/2014/main" id="{3F8275C6-77D0-1357-A7B7-C805BB20D113}"/>
+              </a:ext>
+            </a:extLst>
+          </p:cNvPr>
+          <p:cNvSpPr txBox="1"/>
+          <p:nvPr/>
+        </p:nvSpPr>
+        <p:spPr>
+          <a:xfrm>
+            <a:off x="7321280" y="1955790"/>
+            <a:ext cx="2458150" cy="369332"/>
+          </a:xfrm>
+          <a:prstGeom prst="rect">
+            <a:avLst/>
+          </a:prstGeom>
+          <a:noFill/>
+        </p:spPr>
+        <p:txBody>
+          <a:bodyPr wrap="square" rtlCol="0">
+            <a:spAutoFit/>
+          </a:bodyPr>
+          <a:lstStyle/>
+          <a:p>
+            <a:pPr algn="ctr"/>
+            <a:r>
+              <a:rPr lang="en-US" b="1" dirty="0">
+                <a:latin typeface="Aptos" panose="020B0004020202020204" pitchFamily="34" charset="0"/>
+              </a:rPr>
+              <a:t>c)</a:t>
+            </a:r>
+            <a:r>
+              <a:rPr lang="en-US" b="1" dirty="0">
+                <a:solidFill>
+                  <a:schemeClr val="tx1"/>
+                </a:solidFill>
+                <a:latin typeface="Aptos" panose="020B0004020202020204" pitchFamily="34" charset="0"/>
+              </a:rPr>
+              <a:t> Autoregressive (AR)</a:t>
+            </a:r>
+          </a:p>
+        </p:txBody>
+      </p:sp>
+    </p:spTree>
+    <p:extLst>
+      <p:ext uri="{BB962C8B-B14F-4D97-AF65-F5344CB8AC3E}">
+        <p14:creationId xmlns:p14="http://schemas.microsoft.com/office/powerpoint/2010/main" val="1356583262"/>
+      </p:ext>
+    </p:extLst>
+  </p:cSld>
+  <p:clrMapOvr>
+    <a:masterClrMapping/>
+  </p:clrMapOvr>
+</p:sld>
+</file>
+
+<file path=ppt/slides/slide4.xml><?xml version="1.0" encoding="utf-8"?>
+<p:sld xmlns:a="http://schemas.openxmlformats.org/drawingml/2006/main" xmlns:r="http://schemas.openxmlformats.org/officeDocument/2006/relationships" xmlns:p="http://schemas.openxmlformats.org/presentationml/2006/main">
+  <p:cSld>
+    <p:spTree>
+      <p:nvGrpSpPr>
+        <p:cNvPr id="1" name=""/>
+        <p:cNvGrpSpPr/>
+        <p:nvPr/>
+      </p:nvGrpSpPr>
+      <p:grpSpPr>
+        <a:xfrm>
+          <a:off x="0" y="0"/>
+          <a:ext cx="0" cy="0"/>
+          <a:chOff x="0" y="0"/>
+          <a:chExt cx="0" cy="0"/>
+        </a:xfrm>
+      </p:grpSpPr>
+      <p:sp>
+        <p:nvSpPr>
+          <p:cNvPr id="10" name="TextBox 9">
+            <a:extLst>
+              <a:ext uri="{FF2B5EF4-FFF2-40B4-BE49-F238E27FC236}">
+                <a16:creationId xmlns:a16="http://schemas.microsoft.com/office/drawing/2014/main" id="{1AC15706-19FA-F1F8-50C9-256D40185904}"/>
+              </a:ext>
+            </a:extLst>
+          </p:cNvPr>
+          <p:cNvSpPr txBox="1"/>
+          <p:nvPr/>
+        </p:nvSpPr>
+        <p:spPr>
+          <a:xfrm>
+            <a:off x="8986641" y="81002"/>
+            <a:ext cx="3651354" cy="369332"/>
+          </a:xfrm>
+          <a:prstGeom prst="rect">
+            <a:avLst/>
+          </a:prstGeom>
+          <a:noFill/>
+        </p:spPr>
+        <p:txBody>
+          <a:bodyPr wrap="square" rtlCol="0">
+            <a:spAutoFit/>
+          </a:bodyPr>
+          <a:lstStyle/>
+          <a:p>
+            <a:r>
+              <a:rPr lang="en-US" dirty="0"/>
+              <a:t>Figure 4 concept (</a:t>
+            </a:r>
+            <a:r>
+              <a:rPr lang="en-US" dirty="0" err="1"/>
+              <a:t>NNdzdt</a:t>
+            </a:r>
+            <a:r>
+              <a:rPr lang="en-US" dirty="0"/>
+              <a:t>)</a:t>
+            </a:r>
+          </a:p>
+        </p:txBody>
+      </p:sp>
+      <p:pic>
+        <p:nvPicPr>
+          <p:cNvPr id="18" name="Picture 17">
+            <a:extLst>
+              <a:ext uri="{FF2B5EF4-FFF2-40B4-BE49-F238E27FC236}">
+                <a16:creationId xmlns:a16="http://schemas.microsoft.com/office/drawing/2014/main" id="{E94B7A5B-C913-F31C-05F5-7BF25A18110F}"/>
+              </a:ext>
+            </a:extLst>
+          </p:cNvPr>
+          <p:cNvPicPr>
+            <a:picLocks noChangeAspect="1"/>
+          </p:cNvPicPr>
+          <p:nvPr/>
+        </p:nvPicPr>
+        <p:blipFill>
+          <a:blip r:embed="rId2"/>
+          <a:stretch>
+            <a:fillRect/>
+          </a:stretch>
+        </p:blipFill>
+        <p:spPr>
+          <a:xfrm>
+            <a:off x="1456843" y="265668"/>
+            <a:ext cx="6457951" cy="2870200"/>
+          </a:xfrm>
+          <a:prstGeom prst="rect">
+            <a:avLst/>
+          </a:prstGeom>
+        </p:spPr>
+      </p:pic>
+      <p:pic>
+        <p:nvPicPr>
+          <p:cNvPr id="36" name="Picture 35">
+            <a:extLst>
+              <a:ext uri="{FF2B5EF4-FFF2-40B4-BE49-F238E27FC236}">
+                <a16:creationId xmlns:a16="http://schemas.microsoft.com/office/drawing/2014/main" id="{B89A3767-2AE1-67D8-B2DD-1AA000E5225D}"/>
+              </a:ext>
+            </a:extLst>
+          </p:cNvPr>
+          <p:cNvPicPr>
+            <a:picLocks noChangeAspect="1"/>
+          </p:cNvPicPr>
+          <p:nvPr/>
+        </p:nvPicPr>
+        <p:blipFill>
+          <a:blip r:embed="rId3"/>
+          <a:srcRect l="25163" t="30501" r="26851" b="34140"/>
+          <a:stretch>
+            <a:fillRect/>
+          </a:stretch>
+        </p:blipFill>
+        <p:spPr>
+          <a:xfrm>
+            <a:off x="1472618" y="3082789"/>
+            <a:ext cx="6426400" cy="1420608"/>
+          </a:xfrm>
+          <a:prstGeom prst="rect">
+            <a:avLst/>
+          </a:prstGeom>
+        </p:spPr>
+      </p:pic>
+      <p:sp>
+        <p:nvSpPr>
+          <p:cNvPr id="21" name="TextBox 20">
+            <a:extLst>
+              <a:ext uri="{FF2B5EF4-FFF2-40B4-BE49-F238E27FC236}">
+                <a16:creationId xmlns:a16="http://schemas.microsoft.com/office/drawing/2014/main" id="{E9E2FBCF-1310-E099-5DC1-43F723F20C02}"/>
+              </a:ext>
+            </a:extLst>
+          </p:cNvPr>
+          <p:cNvSpPr txBox="1"/>
+          <p:nvPr/>
+        </p:nvSpPr>
+        <p:spPr>
+          <a:xfrm>
+            <a:off x="1456843" y="265668"/>
+            <a:ext cx="841709" cy="276999"/>
+          </a:xfrm>
+          <a:prstGeom prst="rect">
+            <a:avLst/>
+          </a:prstGeom>
+          <a:noFill/>
+        </p:spPr>
+        <p:txBody>
+          <a:bodyPr wrap="square" rtlCol="0">
+            <a:spAutoFit/>
+          </a:bodyPr>
+          <a:lstStyle/>
+          <a:p>
+            <a:r>
+              <a:rPr lang="en-US" sz="1200" b="1" dirty="0"/>
+              <a:t>a)</a:t>
+            </a:r>
+          </a:p>
+        </p:txBody>
+      </p:sp>
+      <p:sp>
+        <p:nvSpPr>
+          <p:cNvPr id="22" name="TextBox 21">
+            <a:extLst>
+              <a:ext uri="{FF2B5EF4-FFF2-40B4-BE49-F238E27FC236}">
+                <a16:creationId xmlns:a16="http://schemas.microsoft.com/office/drawing/2014/main" id="{0ED42712-F12E-14C4-1513-953CA28B91C6}"/>
+              </a:ext>
+            </a:extLst>
+          </p:cNvPr>
+          <p:cNvSpPr txBox="1"/>
+          <p:nvPr/>
+        </p:nvSpPr>
+        <p:spPr>
+          <a:xfrm>
+            <a:off x="1472618" y="3121223"/>
+            <a:ext cx="1013798" cy="276999"/>
+          </a:xfrm>
+          <a:prstGeom prst="rect">
+            <a:avLst/>
+          </a:prstGeom>
+          <a:noFill/>
+        </p:spPr>
+        <p:txBody>
+          <a:bodyPr wrap="square" rtlCol="0">
+            <a:spAutoFit/>
+          </a:bodyPr>
+          <a:lstStyle/>
+          <a:p>
+            <a:r>
+              <a:rPr lang="en-US" sz="1200" b="1" dirty="0"/>
+              <a:t>b) </a:t>
+            </a:r>
+            <a:r>
+              <a:rPr lang="en-US" sz="1200" dirty="0" err="1"/>
+              <a:t>SINDy</a:t>
+            </a:r>
+            <a:endParaRPr lang="en-US" sz="1200" b="1" dirty="0"/>
+          </a:p>
+        </p:txBody>
+      </p:sp>
+      <p:grpSp>
+        <p:nvGrpSpPr>
+          <p:cNvPr id="30" name="Group 29">
+            <a:extLst>
+              <a:ext uri="{FF2B5EF4-FFF2-40B4-BE49-F238E27FC236}">
+                <a16:creationId xmlns:a16="http://schemas.microsoft.com/office/drawing/2014/main" id="{F95332E1-E96E-6894-2BB9-0788C160B6BA}"/>
+              </a:ext>
+            </a:extLst>
+          </p:cNvPr>
+          <p:cNvGrpSpPr/>
+          <p:nvPr/>
+        </p:nvGrpSpPr>
+        <p:grpSpPr>
+          <a:xfrm>
+            <a:off x="1489979" y="4644687"/>
+            <a:ext cx="6457951" cy="948072"/>
+            <a:chOff x="1270784" y="4947915"/>
+            <a:chExt cx="7715856" cy="1218440"/>
+          </a:xfrm>
+        </p:grpSpPr>
+        <p:pic>
+          <p:nvPicPr>
+            <p:cNvPr id="20" name="Picture 19">
+              <a:extLst>
+                <a:ext uri="{FF2B5EF4-FFF2-40B4-BE49-F238E27FC236}">
+                  <a16:creationId xmlns:a16="http://schemas.microsoft.com/office/drawing/2014/main" id="{53E1E383-A30A-1A4F-AC3F-6D69AAED2D9A}"/>
+                </a:ext>
+              </a:extLst>
+            </p:cNvPr>
+            <p:cNvPicPr>
+              <a:picLocks noChangeAspect="1"/>
+            </p:cNvPicPr>
+            <p:nvPr/>
+          </p:nvPicPr>
+          <p:blipFill>
+            <a:blip r:embed="rId4"/>
+            <a:srcRect l="25551" t="41292" r="26606" b="35304"/>
+            <a:stretch>
+              <a:fillRect/>
+            </a:stretch>
+          </p:blipFill>
+          <p:spPr>
+            <a:xfrm>
+              <a:off x="1270784" y="4947915"/>
+              <a:ext cx="7715856" cy="1132372"/>
+            </a:xfrm>
+            <a:prstGeom prst="rect">
+              <a:avLst/>
+            </a:prstGeom>
+            <a:ln w="19050">
+              <a:noFill/>
+            </a:ln>
+          </p:spPr>
+        </p:pic>
+        <p:sp>
+          <p:nvSpPr>
+            <p:cNvPr id="23" name="Rectangle 22">
+              <a:extLst>
+                <a:ext uri="{FF2B5EF4-FFF2-40B4-BE49-F238E27FC236}">
+                  <a16:creationId xmlns:a16="http://schemas.microsoft.com/office/drawing/2014/main" id="{806A2A18-044D-7325-C995-5E2D6957237E}"/>
+                </a:ext>
+              </a:extLst>
+            </p:cNvPr>
+            <p:cNvSpPr/>
+            <p:nvPr/>
+          </p:nvSpPr>
+          <p:spPr>
+            <a:xfrm>
+              <a:off x="8097864" y="5112369"/>
+              <a:ext cx="61994" cy="790413"/>
+            </a:xfrm>
+            <a:prstGeom prst="rect">
+              <a:avLst/>
+            </a:prstGeom>
+            <a:noFill/>
+            <a:ln>
+              <a:solidFill>
+                <a:schemeClr val="bg1"/>
+              </a:solidFill>
+            </a:ln>
+          </p:spPr>
+          <p:style>
+            <a:lnRef idx="2">
+              <a:schemeClr val="accent2"/>
+            </a:lnRef>
+            <a:fillRef idx="1">
+              <a:schemeClr val="lt1"/>
+            </a:fillRef>
+            <a:effectRef idx="0">
+              <a:schemeClr val="accent2"/>
+            </a:effectRef>
+            <a:fontRef idx="minor">
+              <a:schemeClr val="dk1"/>
+            </a:fontRef>
+          </p:style>
+          <p:txBody>
+            <a:bodyPr rtlCol="0" anchor="ctr"/>
+            <a:lstStyle/>
+            <a:p>
+              <a:pPr algn="ctr"/>
+              <a:endParaRPr lang="en-US"/>
+            </a:p>
+          </p:txBody>
+        </p:sp>
+        <p:sp>
+          <p:nvSpPr>
+            <p:cNvPr id="24" name="Rectangle 23">
+              <a:extLst>
+                <a:ext uri="{FF2B5EF4-FFF2-40B4-BE49-F238E27FC236}">
+                  <a16:creationId xmlns:a16="http://schemas.microsoft.com/office/drawing/2014/main" id="{1968F59C-7DFD-20FF-5566-05C89916F407}"/>
+                </a:ext>
+              </a:extLst>
+            </p:cNvPr>
+            <p:cNvSpPr/>
+            <p:nvPr/>
+          </p:nvSpPr>
+          <p:spPr>
+            <a:xfrm>
+              <a:off x="3104825" y="5111650"/>
+              <a:ext cx="61994" cy="790413"/>
+            </a:xfrm>
+            <a:prstGeom prst="rect">
+              <a:avLst/>
+            </a:prstGeom>
+            <a:noFill/>
+            <a:ln>
+              <a:solidFill>
+                <a:schemeClr val="bg1"/>
+              </a:solidFill>
+            </a:ln>
+          </p:spPr>
+          <p:style>
+            <a:lnRef idx="2">
+              <a:schemeClr val="accent2"/>
+            </a:lnRef>
+            <a:fillRef idx="1">
+              <a:schemeClr val="lt1"/>
+            </a:fillRef>
+            <a:effectRef idx="0">
+              <a:schemeClr val="accent2"/>
+            </a:effectRef>
+            <a:fontRef idx="minor">
+              <a:schemeClr val="dk1"/>
+            </a:fontRef>
+          </p:style>
+          <p:txBody>
+            <a:bodyPr rtlCol="0" anchor="ctr"/>
+            <a:lstStyle/>
+            <a:p>
+              <a:pPr algn="ctr"/>
+              <a:endParaRPr lang="en-US"/>
+            </a:p>
+          </p:txBody>
+        </p:sp>
+        <p:sp>
+          <p:nvSpPr>
+            <p:cNvPr id="25" name="Rectangle 24">
+              <a:extLst>
+                <a:ext uri="{FF2B5EF4-FFF2-40B4-BE49-F238E27FC236}">
+                  <a16:creationId xmlns:a16="http://schemas.microsoft.com/office/drawing/2014/main" id="{85ADE2DD-C830-8AA1-5DBE-97C098FE9F48}"/>
+                </a:ext>
+              </a:extLst>
+            </p:cNvPr>
+            <p:cNvSpPr/>
+            <p:nvPr/>
+          </p:nvSpPr>
+          <p:spPr>
+            <a:xfrm>
+              <a:off x="6364635" y="5112369"/>
+              <a:ext cx="61994" cy="790413"/>
+            </a:xfrm>
+            <a:prstGeom prst="rect">
+              <a:avLst/>
+            </a:prstGeom>
+            <a:noFill/>
+            <a:ln>
+              <a:solidFill>
+                <a:schemeClr val="bg1"/>
+              </a:solidFill>
+            </a:ln>
+          </p:spPr>
+          <p:style>
+            <a:lnRef idx="2">
+              <a:schemeClr val="accent2"/>
+            </a:lnRef>
+            <a:fillRef idx="1">
+              <a:schemeClr val="lt1"/>
+            </a:fillRef>
+            <a:effectRef idx="0">
+              <a:schemeClr val="accent2"/>
+            </a:effectRef>
+            <a:fontRef idx="minor">
+              <a:schemeClr val="dk1"/>
+            </a:fontRef>
+          </p:style>
+          <p:txBody>
+            <a:bodyPr rtlCol="0" anchor="ctr"/>
+            <a:lstStyle/>
+            <a:p>
+              <a:pPr algn="ctr"/>
+              <a:endParaRPr lang="en-US"/>
+            </a:p>
+          </p:txBody>
+        </p:sp>
+        <p:sp>
+          <p:nvSpPr>
+            <p:cNvPr id="26" name="TextBox 25">
+              <a:extLst>
+                <a:ext uri="{FF2B5EF4-FFF2-40B4-BE49-F238E27FC236}">
+                  <a16:creationId xmlns:a16="http://schemas.microsoft.com/office/drawing/2014/main" id="{41E7C119-6CC1-840C-A682-4A0F8BA962D4}"/>
+                </a:ext>
+              </a:extLst>
+            </p:cNvPr>
+            <p:cNvSpPr txBox="1"/>
+            <p:nvPr/>
+          </p:nvSpPr>
+          <p:spPr>
+            <a:xfrm>
+              <a:off x="2921756" y="5881607"/>
+              <a:ext cx="841709" cy="276999"/>
+            </a:xfrm>
+            <a:prstGeom prst="rect">
+              <a:avLst/>
+            </a:prstGeom>
+            <a:noFill/>
+          </p:spPr>
+          <p:txBody>
+            <a:bodyPr wrap="square" rtlCol="0">
+              <a:spAutoFit/>
+            </a:bodyPr>
+            <a:lstStyle/>
+            <a:p>
+              <a:r>
+                <a:rPr lang="en-US" sz="1200" i="1" dirty="0"/>
+                <a:t>P50</a:t>
+              </a:r>
+            </a:p>
+          </p:txBody>
+        </p:sp>
+        <p:sp>
+          <p:nvSpPr>
+            <p:cNvPr id="27" name="TextBox 26">
+              <a:extLst>
+                <a:ext uri="{FF2B5EF4-FFF2-40B4-BE49-F238E27FC236}">
+                  <a16:creationId xmlns:a16="http://schemas.microsoft.com/office/drawing/2014/main" id="{40550AFB-8D2D-4157-EF62-09269555323D}"/>
+                </a:ext>
+              </a:extLst>
+            </p:cNvPr>
+            <p:cNvSpPr txBox="1"/>
+            <p:nvPr/>
+          </p:nvSpPr>
+          <p:spPr>
+            <a:xfrm>
+              <a:off x="6181567" y="5881606"/>
+              <a:ext cx="841709" cy="276999"/>
+            </a:xfrm>
+            <a:prstGeom prst="rect">
+              <a:avLst/>
+            </a:prstGeom>
+            <a:noFill/>
+          </p:spPr>
+          <p:txBody>
+            <a:bodyPr wrap="square" rtlCol="0">
+              <a:spAutoFit/>
+            </a:bodyPr>
+            <a:lstStyle/>
+            <a:p>
+              <a:r>
+                <a:rPr lang="en-US" sz="1200" i="1" dirty="0"/>
+                <a:t>P90</a:t>
+              </a:r>
+            </a:p>
+          </p:txBody>
+        </p:sp>
+        <p:sp>
+          <p:nvSpPr>
+            <p:cNvPr id="28" name="TextBox 27">
+              <a:extLst>
+                <a:ext uri="{FF2B5EF4-FFF2-40B4-BE49-F238E27FC236}">
+                  <a16:creationId xmlns:a16="http://schemas.microsoft.com/office/drawing/2014/main" id="{7B23B2AF-7287-F328-42B6-B782700FEFA6}"/>
+                </a:ext>
+              </a:extLst>
+            </p:cNvPr>
+            <p:cNvSpPr txBox="1"/>
+            <p:nvPr/>
+          </p:nvSpPr>
+          <p:spPr>
+            <a:xfrm>
+              <a:off x="7914794" y="5889356"/>
+              <a:ext cx="841709" cy="276999"/>
+            </a:xfrm>
+            <a:prstGeom prst="rect">
+              <a:avLst/>
+            </a:prstGeom>
+            <a:noFill/>
+          </p:spPr>
+          <p:txBody>
+            <a:bodyPr wrap="square" rtlCol="0">
+              <a:spAutoFit/>
+            </a:bodyPr>
+            <a:lstStyle/>
+            <a:p>
+              <a:r>
+                <a:rPr lang="en-US" sz="1200" i="1" dirty="0"/>
+                <a:t>P10</a:t>
+              </a:r>
+            </a:p>
+          </p:txBody>
+        </p:sp>
+      </p:grpSp>
+      <p:sp>
+        <p:nvSpPr>
+          <p:cNvPr id="31" name="TextBox 30">
+            <a:extLst>
+              <a:ext uri="{FF2B5EF4-FFF2-40B4-BE49-F238E27FC236}">
+                <a16:creationId xmlns:a16="http://schemas.microsoft.com/office/drawing/2014/main" id="{E2C56078-3DE1-C826-3241-A978C08F126A}"/>
+              </a:ext>
+            </a:extLst>
+          </p:cNvPr>
+          <p:cNvSpPr txBox="1"/>
+          <p:nvPr/>
+        </p:nvSpPr>
+        <p:spPr>
+          <a:xfrm>
+            <a:off x="1456841" y="4389363"/>
+            <a:ext cx="1240060" cy="276999"/>
+          </a:xfrm>
+          <a:prstGeom prst="rect">
+            <a:avLst/>
+          </a:prstGeom>
+          <a:noFill/>
+        </p:spPr>
+        <p:txBody>
+          <a:bodyPr wrap="square" rtlCol="0">
+            <a:spAutoFit/>
+          </a:bodyPr>
+          <a:lstStyle/>
+          <a:p>
+            <a:r>
+              <a:rPr lang="en-US" sz="1200" b="1" dirty="0"/>
+              <a:t>c) </a:t>
+            </a:r>
+            <a:r>
+              <a:rPr lang="en-US" sz="1200" dirty="0"/>
+              <a:t>NN-driven*</a:t>
+            </a:r>
+            <a:endParaRPr lang="en-US" sz="1200" b="1" dirty="0"/>
+          </a:p>
+        </p:txBody>
+      </p:sp>
+      <p:sp>
+        <p:nvSpPr>
+          <p:cNvPr id="32" name="TextBox 31">
+            <a:extLst>
+              <a:ext uri="{FF2B5EF4-FFF2-40B4-BE49-F238E27FC236}">
+                <a16:creationId xmlns:a16="http://schemas.microsoft.com/office/drawing/2014/main" id="{BEF1AA45-60D2-6D72-94A7-2D5AC5AD7312}"/>
+              </a:ext>
+            </a:extLst>
+          </p:cNvPr>
+          <p:cNvSpPr txBox="1"/>
+          <p:nvPr/>
+        </p:nvSpPr>
+        <p:spPr>
+          <a:xfrm>
+            <a:off x="1456841" y="5460003"/>
+            <a:ext cx="841709" cy="276999"/>
+          </a:xfrm>
+          <a:prstGeom prst="rect">
+            <a:avLst/>
+          </a:prstGeom>
+          <a:noFill/>
+        </p:spPr>
+        <p:txBody>
+          <a:bodyPr wrap="square" rtlCol="0">
+            <a:spAutoFit/>
+          </a:bodyPr>
+          <a:lstStyle/>
+          <a:p>
+            <a:r>
+              <a:rPr lang="en-US" sz="1200" b="1" dirty="0"/>
+              <a:t>d) </a:t>
+            </a:r>
+            <a:r>
+              <a:rPr lang="en-US" sz="1200" dirty="0"/>
+              <a:t>AR</a:t>
+            </a:r>
+            <a:endParaRPr lang="en-US" sz="1200" b="1" dirty="0"/>
+          </a:p>
+        </p:txBody>
+      </p:sp>
+      <p:pic>
+        <p:nvPicPr>
+          <p:cNvPr id="34" name="Picture 33">
+            <a:extLst>
+              <a:ext uri="{FF2B5EF4-FFF2-40B4-BE49-F238E27FC236}">
+                <a16:creationId xmlns:a16="http://schemas.microsoft.com/office/drawing/2014/main" id="{EAB931B3-373B-3E1C-3561-65BD0004AAEA}"/>
+              </a:ext>
+            </a:extLst>
+          </p:cNvPr>
+          <p:cNvPicPr>
+            <a:picLocks noChangeAspect="1"/>
+          </p:cNvPicPr>
+          <p:nvPr/>
+        </p:nvPicPr>
+        <p:blipFill>
+          <a:blip r:embed="rId5"/>
+          <a:srcRect l="25163" t="41191" r="26613" b="34140"/>
+          <a:stretch>
+            <a:fillRect/>
+          </a:stretch>
+        </p:blipFill>
+        <p:spPr>
+          <a:xfrm>
+            <a:off x="1419874" y="5734050"/>
+            <a:ext cx="6541216" cy="1003862"/>
+          </a:xfrm>
+          <a:prstGeom prst="rect">
+            <a:avLst/>
+          </a:prstGeom>
+        </p:spPr>
+      </p:pic>
+    </p:spTree>
+    <p:extLst>
+      <p:ext uri="{BB962C8B-B14F-4D97-AF65-F5344CB8AC3E}">
+        <p14:creationId xmlns:p14="http://schemas.microsoft.com/office/powerpoint/2010/main" val="3679371250"/>
+      </p:ext>
+    </p:extLst>
+  </p:cSld>
+  <p:clrMapOvr>
+    <a:masterClrMapping/>
+  </p:clrMapOvr>
+</p:sld>
+</file>
+
+<file path=ppt/slides/slide5.xml><?xml version="1.0" encoding="utf-8"?>
+<p:sld xmlns:a="http://schemas.openxmlformats.org/drawingml/2006/main" xmlns:r="http://schemas.openxmlformats.org/officeDocument/2006/relationships" xmlns:p="http://schemas.openxmlformats.org/presentationml/2006/main">
+  <p:cSld>
+    <p:spTree>
+      <p:nvGrpSpPr>
+        <p:cNvPr id="1" name=""/>
+        <p:cNvGrpSpPr/>
+        <p:nvPr/>
+      </p:nvGrpSpPr>
+      <p:grpSpPr>
+        <a:xfrm>
+          <a:off x="0" y="0"/>
+          <a:ext cx="0" cy="0"/>
+          <a:chOff x="0" y="0"/>
+          <a:chExt cx="0" cy="0"/>
+        </a:xfrm>
+      </p:grpSpPr>
+      <p:pic>
+        <p:nvPicPr>
+          <p:cNvPr id="5" name="Picture 4">
+            <a:extLst>
+              <a:ext uri="{FF2B5EF4-FFF2-40B4-BE49-F238E27FC236}">
+                <a16:creationId xmlns:a16="http://schemas.microsoft.com/office/drawing/2014/main" id="{EF9474AD-595A-EBD1-4D17-4E6912AEB38C}"/>
+              </a:ext>
+            </a:extLst>
+          </p:cNvPr>
+          <p:cNvPicPr>
+            <a:picLocks noChangeAspect="1"/>
+          </p:cNvPicPr>
+          <p:nvPr/>
+        </p:nvPicPr>
+        <p:blipFill>
+          <a:blip r:embed="rId2"/>
+          <a:stretch>
+            <a:fillRect/>
+          </a:stretch>
+        </p:blipFill>
+        <p:spPr>
+          <a:xfrm>
+            <a:off x="2545492" y="408830"/>
+            <a:ext cx="4085967" cy="2042984"/>
+          </a:xfrm>
+          <a:prstGeom prst="rect">
+            <a:avLst/>
+          </a:prstGeom>
+        </p:spPr>
+      </p:pic>
+      <p:sp>
+        <p:nvSpPr>
+          <p:cNvPr id="6" name="TextBox 5">
+            <a:extLst>
+              <a:ext uri="{FF2B5EF4-FFF2-40B4-BE49-F238E27FC236}">
+                <a16:creationId xmlns:a16="http://schemas.microsoft.com/office/drawing/2014/main" id="{3943EFA6-50E9-CEBE-D1B3-97626D1A6C08}"/>
+              </a:ext>
+            </a:extLst>
+          </p:cNvPr>
+          <p:cNvSpPr txBox="1"/>
+          <p:nvPr/>
+        </p:nvSpPr>
+        <p:spPr>
+          <a:xfrm>
+            <a:off x="2534657" y="290440"/>
+            <a:ext cx="1013798" cy="261610"/>
+          </a:xfrm>
+          <a:prstGeom prst="rect">
+            <a:avLst/>
+          </a:prstGeom>
+          <a:noFill/>
+        </p:spPr>
+        <p:txBody>
+          <a:bodyPr wrap="square" rtlCol="0">
+            <a:spAutoFit/>
+          </a:bodyPr>
+          <a:lstStyle/>
+          <a:p>
+            <a:r>
+              <a:rPr lang="en-US" sz="1100" b="1" dirty="0"/>
+              <a:t>a) </a:t>
+            </a:r>
+            <a:r>
+              <a:rPr lang="en-US" sz="1100" dirty="0" err="1"/>
+              <a:t>SINDy</a:t>
+            </a:r>
+            <a:endParaRPr lang="en-US" sz="1100" b="1" dirty="0"/>
+          </a:p>
+        </p:txBody>
+      </p:sp>
+      <p:pic>
+        <p:nvPicPr>
+          <p:cNvPr id="10" name="Picture 9">
+            <a:extLst>
+              <a:ext uri="{FF2B5EF4-FFF2-40B4-BE49-F238E27FC236}">
+                <a16:creationId xmlns:a16="http://schemas.microsoft.com/office/drawing/2014/main" id="{20655E92-A156-DBB2-48DD-2433901556F7}"/>
+              </a:ext>
+            </a:extLst>
+          </p:cNvPr>
+          <p:cNvPicPr>
+            <a:picLocks noChangeAspect="1"/>
+          </p:cNvPicPr>
+          <p:nvPr/>
+        </p:nvPicPr>
+        <p:blipFill>
+          <a:blip r:embed="rId3"/>
+          <a:stretch>
+            <a:fillRect/>
+          </a:stretch>
+        </p:blipFill>
+        <p:spPr>
+          <a:xfrm>
+            <a:off x="2545492" y="2582619"/>
+            <a:ext cx="4085967" cy="2042984"/>
+          </a:xfrm>
+          <a:prstGeom prst="rect">
+            <a:avLst/>
+          </a:prstGeom>
+        </p:spPr>
+      </p:pic>
+      <p:sp>
+        <p:nvSpPr>
+          <p:cNvPr id="11" name="TextBox 10">
+            <a:extLst>
+              <a:ext uri="{FF2B5EF4-FFF2-40B4-BE49-F238E27FC236}">
+                <a16:creationId xmlns:a16="http://schemas.microsoft.com/office/drawing/2014/main" id="{0E7B52B4-01D8-0898-7E41-8B0419FB3EE4}"/>
+              </a:ext>
+            </a:extLst>
+          </p:cNvPr>
+          <p:cNvSpPr txBox="1"/>
+          <p:nvPr/>
+        </p:nvSpPr>
+        <p:spPr>
+          <a:xfrm>
+            <a:off x="2457473" y="2486139"/>
+            <a:ext cx="1240060" cy="261610"/>
+          </a:xfrm>
+          <a:prstGeom prst="rect">
+            <a:avLst/>
+          </a:prstGeom>
+          <a:noFill/>
+        </p:spPr>
+        <p:txBody>
+          <a:bodyPr wrap="square" rtlCol="0">
+            <a:spAutoFit/>
+          </a:bodyPr>
+          <a:lstStyle/>
+          <a:p>
+            <a:r>
+              <a:rPr lang="en-US" sz="1100" b="1" dirty="0"/>
+              <a:t>b) </a:t>
+            </a:r>
+            <a:r>
+              <a:rPr lang="en-US" sz="1100" dirty="0"/>
+              <a:t>NN-driven</a:t>
+            </a:r>
+            <a:endParaRPr lang="en-US" sz="1100" b="1" dirty="0"/>
+          </a:p>
+        </p:txBody>
+      </p:sp>
+      <p:pic>
+        <p:nvPicPr>
+          <p:cNvPr id="13" name="Picture 12">
+            <a:extLst>
+              <a:ext uri="{FF2B5EF4-FFF2-40B4-BE49-F238E27FC236}">
+                <a16:creationId xmlns:a16="http://schemas.microsoft.com/office/drawing/2014/main" id="{74AB1E86-D1E8-833F-D3A9-6D08ED0F85E9}"/>
+              </a:ext>
+            </a:extLst>
+          </p:cNvPr>
+          <p:cNvPicPr>
+            <a:picLocks noChangeAspect="1"/>
+          </p:cNvPicPr>
+          <p:nvPr/>
+        </p:nvPicPr>
+        <p:blipFill>
+          <a:blip r:embed="rId4"/>
+          <a:stretch>
+            <a:fillRect/>
+          </a:stretch>
+        </p:blipFill>
+        <p:spPr>
+          <a:xfrm>
+            <a:off x="2534657" y="4691507"/>
+            <a:ext cx="4085968" cy="2042984"/>
+          </a:xfrm>
+          <a:prstGeom prst="rect">
+            <a:avLst/>
+          </a:prstGeom>
+        </p:spPr>
+      </p:pic>
+      <p:sp>
+        <p:nvSpPr>
+          <p:cNvPr id="14" name="TextBox 13">
+            <a:extLst>
+              <a:ext uri="{FF2B5EF4-FFF2-40B4-BE49-F238E27FC236}">
+                <a16:creationId xmlns:a16="http://schemas.microsoft.com/office/drawing/2014/main" id="{1BC1A71A-BE91-75CF-E81F-7AD88F0EFF75}"/>
+              </a:ext>
+            </a:extLst>
+          </p:cNvPr>
+          <p:cNvSpPr txBox="1"/>
+          <p:nvPr/>
+        </p:nvSpPr>
+        <p:spPr>
+          <a:xfrm>
+            <a:off x="2545492" y="4596400"/>
+            <a:ext cx="841709" cy="261610"/>
+          </a:xfrm>
+          <a:prstGeom prst="rect">
+            <a:avLst/>
+          </a:prstGeom>
+          <a:noFill/>
+        </p:spPr>
+        <p:txBody>
+          <a:bodyPr wrap="square" rtlCol="0">
+            <a:spAutoFit/>
+          </a:bodyPr>
+          <a:lstStyle/>
+          <a:p>
+            <a:r>
+              <a:rPr lang="en-US" sz="1100" b="1" dirty="0"/>
+              <a:t>c) </a:t>
+            </a:r>
+            <a:r>
+              <a:rPr lang="en-US" sz="1100" dirty="0"/>
+              <a:t>AR</a:t>
+            </a:r>
+            <a:endParaRPr lang="en-US" sz="1100" b="1" dirty="0"/>
+          </a:p>
+        </p:txBody>
+      </p:sp>
+    </p:spTree>
+    <p:extLst>
+      <p:ext uri="{BB962C8B-B14F-4D97-AF65-F5344CB8AC3E}">
+        <p14:creationId xmlns:p14="http://schemas.microsoft.com/office/powerpoint/2010/main" val="1736462962"/>
+      </p:ext>
+    </p:extLst>
+  </p:cSld>
+  <p:clrMapOvr>
+    <a:masterClrMapping/>
+  </p:clrMapOvr>
+</p:sld>
+</file>
+
+<file path=ppt/slides/slide6.xml><?xml version="1.0" encoding="utf-8"?>
+<p:sld xmlns:a="http://schemas.openxmlformats.org/drawingml/2006/main" xmlns:r="http://schemas.openxmlformats.org/officeDocument/2006/relationships" xmlns:p="http://schemas.openxmlformats.org/presentationml/2006/main">
+  <p:cSld>
+    <p:spTree>
+      <p:nvGrpSpPr>
+        <p:cNvPr id="1" name="">
+          <a:extLst>
+            <a:ext uri="{FF2B5EF4-FFF2-40B4-BE49-F238E27FC236}">
+              <a16:creationId xmlns:a16="http://schemas.microsoft.com/office/drawing/2014/main" id="{22833A9F-1143-B35A-9828-04A5EF283A34}"/>
+            </a:ext>
+          </a:extLst>
+        </p:cNvPr>
+        <p:cNvGrpSpPr/>
+        <p:nvPr/>
+      </p:nvGrpSpPr>
+      <p:grpSpPr>
+        <a:xfrm>
+          <a:off x="0" y="0"/>
+          <a:ext cx="0" cy="0"/>
+          <a:chOff x="0" y="0"/>
+          <a:chExt cx="0" cy="0"/>
+        </a:xfrm>
+      </p:grpSpPr>
+      <p:pic>
+        <p:nvPicPr>
+          <p:cNvPr id="3" name="Picture 2">
+            <a:extLst>
+              <a:ext uri="{FF2B5EF4-FFF2-40B4-BE49-F238E27FC236}">
+                <a16:creationId xmlns:a16="http://schemas.microsoft.com/office/drawing/2014/main" id="{5A694F39-970F-97C9-AAEF-421C6356269C}"/>
+              </a:ext>
+            </a:extLst>
+          </p:cNvPr>
+          <p:cNvPicPr>
+            <a:picLocks noChangeAspect="1"/>
+          </p:cNvPicPr>
+          <p:nvPr/>
+        </p:nvPicPr>
+        <p:blipFill>
+          <a:blip r:embed="rId2"/>
+          <a:stretch>
+            <a:fillRect/>
+          </a:stretch>
+        </p:blipFill>
+        <p:spPr>
+          <a:xfrm>
+            <a:off x="1498630" y="167387"/>
+            <a:ext cx="6400388" cy="2880175"/>
+          </a:xfrm>
+          <a:prstGeom prst="rect">
+            <a:avLst/>
+          </a:prstGeom>
+        </p:spPr>
+      </p:pic>
+      <p:sp>
+        <p:nvSpPr>
+          <p:cNvPr id="10" name="TextBox 9">
+            <a:extLst>
+              <a:ext uri="{FF2B5EF4-FFF2-40B4-BE49-F238E27FC236}">
+                <a16:creationId xmlns:a16="http://schemas.microsoft.com/office/drawing/2014/main" id="{F79C25CB-890F-AD31-7380-E2292CEC071D}"/>
+              </a:ext>
+            </a:extLst>
+          </p:cNvPr>
+          <p:cNvSpPr txBox="1"/>
+          <p:nvPr/>
+        </p:nvSpPr>
+        <p:spPr>
+          <a:xfrm>
+            <a:off x="8986641" y="81002"/>
+            <a:ext cx="3651354" cy="369332"/>
+          </a:xfrm>
+          <a:prstGeom prst="rect">
+            <a:avLst/>
+          </a:prstGeom>
+          <a:noFill/>
+        </p:spPr>
+        <p:txBody>
+          <a:bodyPr wrap="square" rtlCol="0">
+            <a:spAutoFit/>
+          </a:bodyPr>
+          <a:lstStyle/>
+          <a:p>
+            <a:r>
+              <a:rPr lang="en-US" dirty="0"/>
+              <a:t>Figure 6 concept (</a:t>
+            </a:r>
+            <a:r>
+              <a:rPr lang="en-US" dirty="0" err="1"/>
+              <a:t>NNdzdt</a:t>
+            </a:r>
+            <a:r>
+              <a:rPr lang="en-US" dirty="0"/>
+              <a:t>)</a:t>
+            </a:r>
+          </a:p>
+        </p:txBody>
+      </p:sp>
+      <p:pic>
+        <p:nvPicPr>
+          <p:cNvPr id="5" name="Picture 4">
+            <a:extLst>
+              <a:ext uri="{FF2B5EF4-FFF2-40B4-BE49-F238E27FC236}">
+                <a16:creationId xmlns:a16="http://schemas.microsoft.com/office/drawing/2014/main" id="{6D16E929-6A65-B67E-D260-12BDE50EF2D8}"/>
+              </a:ext>
+            </a:extLst>
+          </p:cNvPr>
+          <p:cNvPicPr>
+            <a:picLocks noChangeAspect="1"/>
+          </p:cNvPicPr>
+          <p:nvPr/>
+        </p:nvPicPr>
+        <p:blipFill>
+          <a:blip r:embed="rId3"/>
+          <a:srcRect t="32153" b="35673"/>
+          <a:stretch>
+            <a:fillRect/>
+          </a:stretch>
+        </p:blipFill>
+        <p:spPr>
+          <a:xfrm>
+            <a:off x="1419874" y="3121223"/>
+            <a:ext cx="6541216" cy="1262754"/>
+          </a:xfrm>
+          <a:prstGeom prst="rect">
+            <a:avLst/>
+          </a:prstGeom>
+        </p:spPr>
+      </p:pic>
+      <p:sp>
+        <p:nvSpPr>
+          <p:cNvPr id="21" name="TextBox 20">
+            <a:extLst>
+              <a:ext uri="{FF2B5EF4-FFF2-40B4-BE49-F238E27FC236}">
+                <a16:creationId xmlns:a16="http://schemas.microsoft.com/office/drawing/2014/main" id="{1D67421B-EBAE-967E-0B04-566DE651F3A1}"/>
+              </a:ext>
+            </a:extLst>
+          </p:cNvPr>
+          <p:cNvSpPr txBox="1"/>
+          <p:nvPr/>
+        </p:nvSpPr>
+        <p:spPr>
+          <a:xfrm>
+            <a:off x="1456843" y="265668"/>
+            <a:ext cx="841709" cy="276999"/>
+          </a:xfrm>
+          <a:prstGeom prst="rect">
+            <a:avLst/>
+          </a:prstGeom>
+          <a:noFill/>
+        </p:spPr>
+        <p:txBody>
+          <a:bodyPr wrap="square" rtlCol="0">
+            <a:spAutoFit/>
+          </a:bodyPr>
+          <a:lstStyle/>
+          <a:p>
+            <a:r>
+              <a:rPr lang="en-US" sz="1200" b="1" dirty="0"/>
+              <a:t>a)</a:t>
+            </a:r>
+          </a:p>
+        </p:txBody>
+      </p:sp>
+      <p:sp>
+        <p:nvSpPr>
+          <p:cNvPr id="22" name="TextBox 21">
+            <a:extLst>
+              <a:ext uri="{FF2B5EF4-FFF2-40B4-BE49-F238E27FC236}">
+                <a16:creationId xmlns:a16="http://schemas.microsoft.com/office/drawing/2014/main" id="{6E62F884-791D-56BE-79C6-CF77C4B9FD76}"/>
+              </a:ext>
+            </a:extLst>
+          </p:cNvPr>
+          <p:cNvSpPr txBox="1"/>
+          <p:nvPr/>
+        </p:nvSpPr>
+        <p:spPr>
+          <a:xfrm>
+            <a:off x="1472618" y="3121223"/>
+            <a:ext cx="1013798" cy="276999"/>
+          </a:xfrm>
+          <a:prstGeom prst="rect">
+            <a:avLst/>
+          </a:prstGeom>
+          <a:noFill/>
+        </p:spPr>
+        <p:txBody>
+          <a:bodyPr wrap="square" rtlCol="0">
+            <a:spAutoFit/>
+          </a:bodyPr>
+          <a:lstStyle/>
+          <a:p>
+            <a:r>
+              <a:rPr lang="en-US" sz="1200" b="1" dirty="0"/>
+              <a:t>b) </a:t>
+            </a:r>
+            <a:r>
+              <a:rPr lang="en-US" sz="1200" dirty="0" err="1"/>
+              <a:t>SINDy</a:t>
+            </a:r>
+            <a:endParaRPr lang="en-US" sz="1200" b="1" dirty="0"/>
+          </a:p>
+        </p:txBody>
+      </p:sp>
+      <p:sp>
+        <p:nvSpPr>
+          <p:cNvPr id="31" name="TextBox 30">
+            <a:extLst>
+              <a:ext uri="{FF2B5EF4-FFF2-40B4-BE49-F238E27FC236}">
+                <a16:creationId xmlns:a16="http://schemas.microsoft.com/office/drawing/2014/main" id="{7E52A0E3-CDEA-4573-3335-AA9D6E0AC4D5}"/>
+              </a:ext>
+            </a:extLst>
+          </p:cNvPr>
+          <p:cNvSpPr txBox="1"/>
+          <p:nvPr/>
+        </p:nvSpPr>
+        <p:spPr>
+          <a:xfrm>
+            <a:off x="1456841" y="4389363"/>
+            <a:ext cx="1240060" cy="276999"/>
+          </a:xfrm>
+          <a:prstGeom prst="rect">
+            <a:avLst/>
+          </a:prstGeom>
+          <a:noFill/>
+        </p:spPr>
+        <p:txBody>
+          <a:bodyPr wrap="square" rtlCol="0">
+            <a:spAutoFit/>
+          </a:bodyPr>
+          <a:lstStyle/>
+          <a:p>
+            <a:r>
+              <a:rPr lang="en-US" sz="1200" b="1" dirty="0"/>
+              <a:t>c) </a:t>
+            </a:r>
+            <a:r>
+              <a:rPr lang="en-US" sz="1200" dirty="0"/>
+              <a:t>NN-driven*</a:t>
+            </a:r>
+            <a:endParaRPr lang="en-US" sz="1200" b="1" dirty="0"/>
+          </a:p>
+        </p:txBody>
+      </p:sp>
+      <p:sp>
+        <p:nvSpPr>
+          <p:cNvPr id="32" name="TextBox 31">
+            <a:extLst>
+              <a:ext uri="{FF2B5EF4-FFF2-40B4-BE49-F238E27FC236}">
+                <a16:creationId xmlns:a16="http://schemas.microsoft.com/office/drawing/2014/main" id="{3146527C-BE20-5AFF-EBFD-EBAF34970DAA}"/>
+              </a:ext>
+            </a:extLst>
+          </p:cNvPr>
+          <p:cNvSpPr txBox="1"/>
+          <p:nvPr/>
+        </p:nvSpPr>
+        <p:spPr>
+          <a:xfrm>
+            <a:off x="1456841" y="5460003"/>
+            <a:ext cx="841709" cy="276999"/>
+          </a:xfrm>
+          <a:prstGeom prst="rect">
+            <a:avLst/>
+          </a:prstGeom>
+          <a:noFill/>
+        </p:spPr>
+        <p:txBody>
+          <a:bodyPr wrap="square" rtlCol="0">
+            <a:spAutoFit/>
+          </a:bodyPr>
+          <a:lstStyle/>
+          <a:p>
+            <a:r>
+              <a:rPr lang="en-US" sz="1200" b="1" dirty="0"/>
+              <a:t>d) </a:t>
+            </a:r>
+            <a:r>
+              <a:rPr lang="en-US" sz="1200" dirty="0"/>
+              <a:t>AR</a:t>
+            </a:r>
+            <a:endParaRPr lang="en-US" sz="1200" b="1" dirty="0"/>
+          </a:p>
+        </p:txBody>
+      </p:sp>
+      <p:pic>
+        <p:nvPicPr>
+          <p:cNvPr id="7" name="Picture 6">
+            <a:extLst>
+              <a:ext uri="{FF2B5EF4-FFF2-40B4-BE49-F238E27FC236}">
+                <a16:creationId xmlns:a16="http://schemas.microsoft.com/office/drawing/2014/main" id="{69E37D20-54FD-AE17-F7A6-585A0C8548EF}"/>
+              </a:ext>
+            </a:extLst>
+          </p:cNvPr>
+          <p:cNvPicPr>
+            <a:picLocks noChangeAspect="1"/>
+          </p:cNvPicPr>
+          <p:nvPr/>
+        </p:nvPicPr>
+        <p:blipFill>
+          <a:blip r:embed="rId4"/>
+          <a:srcRect t="41998" b="36391"/>
+          <a:stretch>
+            <a:fillRect/>
+          </a:stretch>
+        </p:blipFill>
+        <p:spPr>
+          <a:xfrm>
+            <a:off x="1419874" y="4611850"/>
+            <a:ext cx="6541216" cy="848153"/>
+          </a:xfrm>
+          <a:prstGeom prst="rect">
+            <a:avLst/>
+          </a:prstGeom>
+        </p:spPr>
+      </p:pic>
+      <p:pic>
+        <p:nvPicPr>
+          <p:cNvPr id="9" name="Picture 8">
+            <a:extLst>
+              <a:ext uri="{FF2B5EF4-FFF2-40B4-BE49-F238E27FC236}">
+                <a16:creationId xmlns:a16="http://schemas.microsoft.com/office/drawing/2014/main" id="{28404A84-4B15-A024-278A-A2F3821DBF13}"/>
+              </a:ext>
+            </a:extLst>
+          </p:cNvPr>
+          <p:cNvPicPr>
+            <a:picLocks noChangeAspect="1"/>
+          </p:cNvPicPr>
+          <p:nvPr/>
+        </p:nvPicPr>
+        <p:blipFill>
+          <a:blip r:embed="rId5"/>
+          <a:srcRect t="41998" b="35745"/>
+          <a:stretch>
+            <a:fillRect/>
+          </a:stretch>
+        </p:blipFill>
+        <p:spPr>
+          <a:xfrm>
+            <a:off x="1419874" y="5688559"/>
+            <a:ext cx="6541216" cy="873549"/>
+          </a:xfrm>
+          <a:prstGeom prst="rect">
+            <a:avLst/>
+          </a:prstGeom>
+        </p:spPr>
+      </p:pic>
+      <p:sp>
+        <p:nvSpPr>
+          <p:cNvPr id="11" name="Rectangle 10">
+            <a:extLst>
+              <a:ext uri="{FF2B5EF4-FFF2-40B4-BE49-F238E27FC236}">
+                <a16:creationId xmlns:a16="http://schemas.microsoft.com/office/drawing/2014/main" id="{19D2A339-2D89-085D-23ED-8CDAC6B960F4}"/>
+              </a:ext>
+            </a:extLst>
+          </p:cNvPr>
+          <p:cNvSpPr/>
+          <p:nvPr/>
+        </p:nvSpPr>
+        <p:spPr>
+          <a:xfrm>
+            <a:off x="6301780" y="3665285"/>
+            <a:ext cx="45719" cy="2872758"/>
+          </a:xfrm>
+          <a:prstGeom prst="rect">
+            <a:avLst/>
+          </a:prstGeom>
+          <a:noFill/>
+          <a:ln>
+            <a:solidFill>
+              <a:schemeClr val="bg1"/>
+            </a:solidFill>
+          </a:ln>
+        </p:spPr>
+        <p:style>
+          <a:lnRef idx="2">
+            <a:schemeClr val="accent2"/>
+          </a:lnRef>
+          <a:fillRef idx="1">
+            <a:schemeClr val="lt1"/>
+          </a:fillRef>
+          <a:effectRef idx="0">
+            <a:schemeClr val="accent2"/>
+          </a:effectRef>
+          <a:fontRef idx="minor">
+            <a:schemeClr val="dk1"/>
+          </a:fontRef>
+        </p:style>
+        <p:txBody>
+          <a:bodyPr rtlCol="0" anchor="ctr"/>
+          <a:lstStyle/>
+          <a:p>
+            <a:pPr algn="ctr"/>
+            <a:endParaRPr lang="en-US"/>
+          </a:p>
+        </p:txBody>
+      </p:sp>
+      <p:sp>
+        <p:nvSpPr>
+          <p:cNvPr id="12" name="TextBox 11">
+            <a:extLst>
+              <a:ext uri="{FF2B5EF4-FFF2-40B4-BE49-F238E27FC236}">
+                <a16:creationId xmlns:a16="http://schemas.microsoft.com/office/drawing/2014/main" id="{5D0A600B-C457-F588-64FE-38DE6B29BD22}"/>
+              </a:ext>
+            </a:extLst>
+          </p:cNvPr>
+          <p:cNvSpPr txBox="1"/>
+          <p:nvPr/>
+        </p:nvSpPr>
+        <p:spPr>
+          <a:xfrm>
+            <a:off x="6099829" y="6453084"/>
+            <a:ext cx="704486" cy="261610"/>
+          </a:xfrm>
+          <a:prstGeom prst="rect">
+            <a:avLst/>
+          </a:prstGeom>
+          <a:noFill/>
+        </p:spPr>
+        <p:txBody>
+          <a:bodyPr wrap="square" rtlCol="0">
+            <a:spAutoFit/>
+          </a:bodyPr>
+          <a:lstStyle/>
+          <a:p>
+            <a:r>
+              <a:rPr lang="en-US" sz="1050" i="1" dirty="0"/>
+              <a:t>P5</a:t>
+            </a:r>
+          </a:p>
+        </p:txBody>
+      </p:sp>
+      <p:sp>
+        <p:nvSpPr>
+          <p:cNvPr id="14" name="Rectangle 13">
+            <a:extLst>
+              <a:ext uri="{FF2B5EF4-FFF2-40B4-BE49-F238E27FC236}">
+                <a16:creationId xmlns:a16="http://schemas.microsoft.com/office/drawing/2014/main" id="{82416DC7-C611-E1EE-8FE3-4FEDEC06BB01}"/>
+              </a:ext>
+            </a:extLst>
+          </p:cNvPr>
+          <p:cNvSpPr/>
+          <p:nvPr/>
+        </p:nvSpPr>
+        <p:spPr>
+          <a:xfrm>
+            <a:off x="6646427" y="3652754"/>
+            <a:ext cx="45719" cy="730539"/>
+          </a:xfrm>
+          <a:prstGeom prst="rect">
+            <a:avLst/>
+          </a:prstGeom>
+          <a:noFill/>
+          <a:ln>
+            <a:solidFill>
+              <a:schemeClr val="bg1"/>
+            </a:solidFill>
+          </a:ln>
+        </p:spPr>
+        <p:style>
+          <a:lnRef idx="2">
+            <a:schemeClr val="accent2"/>
+          </a:lnRef>
+          <a:fillRef idx="1">
+            <a:schemeClr val="lt1"/>
+          </a:fillRef>
+          <a:effectRef idx="0">
+            <a:schemeClr val="accent2"/>
+          </a:effectRef>
+          <a:fontRef idx="minor">
+            <a:schemeClr val="dk1"/>
+          </a:fontRef>
+        </p:style>
+        <p:txBody>
+          <a:bodyPr rtlCol="0" anchor="ctr"/>
+          <a:lstStyle/>
+          <a:p>
+            <a:pPr algn="ctr"/>
+            <a:endParaRPr lang="en-US"/>
+          </a:p>
+        </p:txBody>
+      </p:sp>
+      <p:sp>
+        <p:nvSpPr>
+          <p:cNvPr id="15" name="TextBox 14">
+            <a:extLst>
+              <a:ext uri="{FF2B5EF4-FFF2-40B4-BE49-F238E27FC236}">
+                <a16:creationId xmlns:a16="http://schemas.microsoft.com/office/drawing/2014/main" id="{9BBDC054-2ADA-A82F-B1EB-27537093A0E1}"/>
+              </a:ext>
+            </a:extLst>
+          </p:cNvPr>
+          <p:cNvSpPr txBox="1"/>
+          <p:nvPr/>
+        </p:nvSpPr>
+        <p:spPr>
+          <a:xfrm>
+            <a:off x="6547851" y="6455008"/>
+            <a:ext cx="704486" cy="261610"/>
+          </a:xfrm>
+          <a:prstGeom prst="rect">
+            <a:avLst/>
+          </a:prstGeom>
+          <a:noFill/>
+        </p:spPr>
+        <p:txBody>
+          <a:bodyPr wrap="square" rtlCol="0">
+            <a:spAutoFit/>
+          </a:bodyPr>
+          <a:lstStyle/>
+          <a:p>
+            <a:r>
+              <a:rPr lang="en-US" sz="1050" i="1" dirty="0"/>
+              <a:t>P25</a:t>
+            </a:r>
+          </a:p>
+        </p:txBody>
+      </p:sp>
+      <p:sp>
+        <p:nvSpPr>
+          <p:cNvPr id="16" name="Rectangle 15">
+            <a:extLst>
+              <a:ext uri="{FF2B5EF4-FFF2-40B4-BE49-F238E27FC236}">
+                <a16:creationId xmlns:a16="http://schemas.microsoft.com/office/drawing/2014/main" id="{D0E2B3F0-7BEC-CA63-AB30-0AD9881FD89D}"/>
+              </a:ext>
+            </a:extLst>
+          </p:cNvPr>
+          <p:cNvSpPr/>
+          <p:nvPr/>
+        </p:nvSpPr>
+        <p:spPr>
+          <a:xfrm>
+            <a:off x="6401272" y="3634838"/>
+            <a:ext cx="45719" cy="2872758"/>
+          </a:xfrm>
+          <a:prstGeom prst="rect">
+            <a:avLst/>
+          </a:prstGeom>
+          <a:noFill/>
+          <a:ln>
+            <a:solidFill>
+              <a:schemeClr val="bg1"/>
+            </a:solidFill>
+          </a:ln>
+        </p:spPr>
+        <p:style>
+          <a:lnRef idx="2">
+            <a:schemeClr val="accent2"/>
+          </a:lnRef>
+          <a:fillRef idx="1">
+            <a:schemeClr val="lt1"/>
+          </a:fillRef>
+          <a:effectRef idx="0">
+            <a:schemeClr val="accent2"/>
+          </a:effectRef>
+          <a:fontRef idx="minor">
+            <a:schemeClr val="dk1"/>
+          </a:fontRef>
+        </p:style>
+        <p:txBody>
+          <a:bodyPr rtlCol="0" anchor="ctr"/>
+          <a:lstStyle/>
+          <a:p>
+            <a:pPr algn="ctr"/>
+            <a:endParaRPr lang="en-US"/>
+          </a:p>
+        </p:txBody>
+      </p:sp>
+      <p:sp>
+        <p:nvSpPr>
+          <p:cNvPr id="17" name="TextBox 16">
+            <a:extLst>
+              <a:ext uri="{FF2B5EF4-FFF2-40B4-BE49-F238E27FC236}">
+                <a16:creationId xmlns:a16="http://schemas.microsoft.com/office/drawing/2014/main" id="{22965D34-05F5-0730-0688-4F6D29F23B64}"/>
+              </a:ext>
+            </a:extLst>
+          </p:cNvPr>
+          <p:cNvSpPr txBox="1"/>
+          <p:nvPr/>
+        </p:nvSpPr>
+        <p:spPr>
+          <a:xfrm>
+            <a:off x="6294184" y="6453084"/>
+            <a:ext cx="459331" cy="261610"/>
+          </a:xfrm>
+          <a:prstGeom prst="rect">
+            <a:avLst/>
+          </a:prstGeom>
+          <a:noFill/>
+        </p:spPr>
+        <p:txBody>
+          <a:bodyPr wrap="square" rtlCol="0">
+            <a:spAutoFit/>
+          </a:bodyPr>
+          <a:lstStyle/>
+          <a:p>
+            <a:r>
+              <a:rPr lang="en-US" sz="1050" i="1" dirty="0"/>
+              <a:t>P50</a:t>
+            </a:r>
+          </a:p>
+        </p:txBody>
+      </p:sp>
+      <p:sp>
+        <p:nvSpPr>
+          <p:cNvPr id="19" name="Rectangle 18">
+            <a:extLst>
+              <a:ext uri="{FF2B5EF4-FFF2-40B4-BE49-F238E27FC236}">
+                <a16:creationId xmlns:a16="http://schemas.microsoft.com/office/drawing/2014/main" id="{320DCEEB-7A41-8B19-9225-4A2FF4C76745}"/>
+              </a:ext>
+            </a:extLst>
+          </p:cNvPr>
+          <p:cNvSpPr/>
+          <p:nvPr/>
+        </p:nvSpPr>
+        <p:spPr>
+          <a:xfrm>
+            <a:off x="2808359" y="3652755"/>
+            <a:ext cx="45719" cy="688239"/>
+          </a:xfrm>
+          <a:prstGeom prst="rect">
+            <a:avLst/>
+          </a:prstGeom>
+          <a:noFill/>
+          <a:ln>
+            <a:solidFill>
+              <a:schemeClr val="bg1"/>
+            </a:solidFill>
+          </a:ln>
+        </p:spPr>
+        <p:style>
+          <a:lnRef idx="2">
+            <a:schemeClr val="accent2"/>
+          </a:lnRef>
+          <a:fillRef idx="1">
+            <a:schemeClr val="lt1"/>
+          </a:fillRef>
+          <a:effectRef idx="0">
+            <a:schemeClr val="accent2"/>
+          </a:effectRef>
+          <a:fontRef idx="minor">
+            <a:schemeClr val="dk1"/>
+          </a:fontRef>
+        </p:style>
+        <p:txBody>
+          <a:bodyPr rtlCol="0" anchor="ctr"/>
+          <a:lstStyle/>
+          <a:p>
+            <a:pPr algn="ctr"/>
+            <a:endParaRPr lang="en-US"/>
+          </a:p>
+        </p:txBody>
+      </p:sp>
+      <p:sp>
+        <p:nvSpPr>
+          <p:cNvPr id="29" name="TextBox 28">
+            <a:extLst>
+              <a:ext uri="{FF2B5EF4-FFF2-40B4-BE49-F238E27FC236}">
+                <a16:creationId xmlns:a16="http://schemas.microsoft.com/office/drawing/2014/main" id="{C44F9334-2536-7221-76AD-4DD100651570}"/>
+              </a:ext>
+            </a:extLst>
+          </p:cNvPr>
+          <p:cNvSpPr txBox="1"/>
+          <p:nvPr/>
+        </p:nvSpPr>
+        <p:spPr>
+          <a:xfrm>
+            <a:off x="2642601" y="6459929"/>
+            <a:ext cx="704486" cy="261610"/>
+          </a:xfrm>
+          <a:prstGeom prst="rect">
+            <a:avLst/>
+          </a:prstGeom>
+          <a:noFill/>
+        </p:spPr>
+        <p:txBody>
+          <a:bodyPr wrap="square" rtlCol="0">
+            <a:spAutoFit/>
+          </a:bodyPr>
+          <a:lstStyle/>
+          <a:p>
+            <a:r>
+              <a:rPr lang="en-US" sz="1050" i="1" dirty="0"/>
+              <a:t>P75</a:t>
+            </a:r>
+          </a:p>
+        </p:txBody>
+      </p:sp>
+      <p:sp>
+        <p:nvSpPr>
+          <p:cNvPr id="33" name="Rectangle 32">
+            <a:extLst>
+              <a:ext uri="{FF2B5EF4-FFF2-40B4-BE49-F238E27FC236}">
+                <a16:creationId xmlns:a16="http://schemas.microsoft.com/office/drawing/2014/main" id="{90E05789-5089-0136-B22F-3B8047594817}"/>
+              </a:ext>
+            </a:extLst>
+          </p:cNvPr>
+          <p:cNvSpPr/>
+          <p:nvPr/>
+        </p:nvSpPr>
+        <p:spPr>
+          <a:xfrm>
+            <a:off x="6646427" y="4782548"/>
+            <a:ext cx="45719" cy="730539"/>
+          </a:xfrm>
+          <a:prstGeom prst="rect">
+            <a:avLst/>
+          </a:prstGeom>
+          <a:noFill/>
+          <a:ln>
+            <a:solidFill>
+              <a:schemeClr val="bg1"/>
+            </a:solidFill>
+          </a:ln>
+        </p:spPr>
+        <p:style>
+          <a:lnRef idx="2">
+            <a:schemeClr val="accent2"/>
+          </a:lnRef>
+          <a:fillRef idx="1">
+            <a:schemeClr val="lt1"/>
+          </a:fillRef>
+          <a:effectRef idx="0">
+            <a:schemeClr val="accent2"/>
+          </a:effectRef>
+          <a:fontRef idx="minor">
+            <a:schemeClr val="dk1"/>
+          </a:fontRef>
+        </p:style>
+        <p:txBody>
+          <a:bodyPr rtlCol="0" anchor="ctr"/>
+          <a:lstStyle/>
+          <a:p>
+            <a:pPr algn="ctr"/>
+            <a:endParaRPr lang="en-US"/>
+          </a:p>
+        </p:txBody>
+      </p:sp>
+      <p:sp>
+        <p:nvSpPr>
+          <p:cNvPr id="35" name="Rectangle 34">
+            <a:extLst>
+              <a:ext uri="{FF2B5EF4-FFF2-40B4-BE49-F238E27FC236}">
+                <a16:creationId xmlns:a16="http://schemas.microsoft.com/office/drawing/2014/main" id="{05F29C22-400C-84DC-A7BF-3D840740C484}"/>
+              </a:ext>
+            </a:extLst>
+          </p:cNvPr>
+          <p:cNvSpPr/>
+          <p:nvPr/>
+        </p:nvSpPr>
+        <p:spPr>
+          <a:xfrm>
+            <a:off x="6646426" y="5813659"/>
+            <a:ext cx="54232" cy="693937"/>
+          </a:xfrm>
+          <a:prstGeom prst="rect">
+            <a:avLst/>
+          </a:prstGeom>
+          <a:noFill/>
+          <a:ln>
+            <a:solidFill>
+              <a:schemeClr val="bg1"/>
+            </a:solidFill>
+          </a:ln>
+        </p:spPr>
+        <p:style>
+          <a:lnRef idx="2">
+            <a:schemeClr val="accent2"/>
+          </a:lnRef>
+          <a:fillRef idx="1">
+            <a:schemeClr val="lt1"/>
+          </a:fillRef>
+          <a:effectRef idx="0">
+            <a:schemeClr val="accent2"/>
+          </a:effectRef>
+          <a:fontRef idx="minor">
+            <a:schemeClr val="dk1"/>
+          </a:fontRef>
+        </p:style>
+        <p:txBody>
+          <a:bodyPr rtlCol="0" anchor="ctr"/>
+          <a:lstStyle/>
+          <a:p>
+            <a:pPr algn="ctr"/>
+            <a:endParaRPr lang="en-US"/>
+          </a:p>
+        </p:txBody>
+      </p:sp>
+      <p:sp>
+        <p:nvSpPr>
+          <p:cNvPr id="37" name="Rectangle 36">
+            <a:extLst>
+              <a:ext uri="{FF2B5EF4-FFF2-40B4-BE49-F238E27FC236}">
+                <a16:creationId xmlns:a16="http://schemas.microsoft.com/office/drawing/2014/main" id="{11E8E405-1451-24BB-DC99-8A019728D276}"/>
+              </a:ext>
+            </a:extLst>
+          </p:cNvPr>
+          <p:cNvSpPr/>
+          <p:nvPr/>
+        </p:nvSpPr>
+        <p:spPr>
+          <a:xfrm>
+            <a:off x="2804102" y="4765395"/>
+            <a:ext cx="54232" cy="693937"/>
+          </a:xfrm>
+          <a:prstGeom prst="rect">
+            <a:avLst/>
+          </a:prstGeom>
+          <a:noFill/>
+          <a:ln>
+            <a:solidFill>
+              <a:schemeClr val="bg1"/>
+            </a:solidFill>
+          </a:ln>
+        </p:spPr>
+        <p:style>
+          <a:lnRef idx="2">
+            <a:schemeClr val="accent2"/>
+          </a:lnRef>
+          <a:fillRef idx="1">
+            <a:schemeClr val="lt1"/>
+          </a:fillRef>
+          <a:effectRef idx="0">
+            <a:schemeClr val="accent2"/>
+          </a:effectRef>
+          <a:fontRef idx="minor">
+            <a:schemeClr val="dk1"/>
+          </a:fontRef>
+        </p:style>
+        <p:txBody>
+          <a:bodyPr rtlCol="0" anchor="ctr"/>
+          <a:lstStyle/>
+          <a:p>
+            <a:pPr algn="ctr"/>
+            <a:endParaRPr lang="en-US"/>
+          </a:p>
+        </p:txBody>
+      </p:sp>
+      <p:sp>
+        <p:nvSpPr>
+          <p:cNvPr id="38" name="Rectangle 37">
+            <a:extLst>
+              <a:ext uri="{FF2B5EF4-FFF2-40B4-BE49-F238E27FC236}">
+                <a16:creationId xmlns:a16="http://schemas.microsoft.com/office/drawing/2014/main" id="{B5D93E19-6A82-FE05-F233-AE6A193CD1F8}"/>
+              </a:ext>
+            </a:extLst>
+          </p:cNvPr>
+          <p:cNvSpPr/>
+          <p:nvPr/>
+        </p:nvSpPr>
+        <p:spPr>
+          <a:xfrm>
+            <a:off x="2804102" y="5813659"/>
+            <a:ext cx="54232" cy="693937"/>
+          </a:xfrm>
+          <a:prstGeom prst="rect">
+            <a:avLst/>
+          </a:prstGeom>
+          <a:noFill/>
+          <a:ln>
+            <a:solidFill>
+              <a:schemeClr val="bg1"/>
+            </a:solidFill>
+          </a:ln>
+        </p:spPr>
+        <p:style>
+          <a:lnRef idx="2">
+            <a:schemeClr val="accent2"/>
+          </a:lnRef>
+          <a:fillRef idx="1">
+            <a:schemeClr val="lt1"/>
+          </a:fillRef>
+          <a:effectRef idx="0">
+            <a:schemeClr val="accent2"/>
+          </a:effectRef>
+          <a:fontRef idx="minor">
+            <a:schemeClr val="dk1"/>
+          </a:fontRef>
+        </p:style>
+        <p:txBody>
+          <a:bodyPr rtlCol="0" anchor="ctr"/>
+          <a:lstStyle/>
+          <a:p>
+            <a:pPr algn="ctr"/>
+            <a:endParaRPr lang="en-US"/>
+          </a:p>
+        </p:txBody>
+      </p:sp>
+    </p:spTree>
+    <p:extLst>
+      <p:ext uri="{BB962C8B-B14F-4D97-AF65-F5344CB8AC3E}">
+        <p14:creationId xmlns:p14="http://schemas.microsoft.com/office/powerpoint/2010/main" val="3846216359"/>
       </p:ext>
     </p:extLst>
   </p:cSld>

</xml_diff>

<commit_message>
update latent trajectories fig
</commit_message>
<xml_diff>
--- a/figures/fig1_diagram.pptx
+++ b/figures/fig1_diagram.pptx
@@ -10,7 +10,8 @@
     <p:sldId id="265" r:id="rId4"/>
     <p:sldId id="266" r:id="rId5"/>
     <p:sldId id="267" r:id="rId6"/>
-    <p:sldId id="268" r:id="rId7"/>
+    <p:sldId id="269" r:id="rId7"/>
+    <p:sldId id="268" r:id="rId8"/>
   </p:sldIdLst>
   <p:sldSz cx="12192000" cy="6858000"/>
   <p:notesSz cx="6858000" cy="9144000"/>
@@ -264,7 +265,7 @@
           <a:p>
             <a:fld id="{75A9CF98-CC55-774D-9AE2-4D7D2CE05F38}" type="datetimeFigureOut">
               <a:rPr lang="en-US" smtClean="0"/>
-              <a:t>9/8/25</a:t>
+              <a:t>9/9/25</a:t>
             </a:fld>
             <a:endParaRPr lang="en-US"/>
           </a:p>
@@ -462,7 +463,7 @@
           <a:p>
             <a:fld id="{75A9CF98-CC55-774D-9AE2-4D7D2CE05F38}" type="datetimeFigureOut">
               <a:rPr lang="en-US" smtClean="0"/>
-              <a:t>9/8/25</a:t>
+              <a:t>9/9/25</a:t>
             </a:fld>
             <a:endParaRPr lang="en-US"/>
           </a:p>
@@ -670,7 +671,7 @@
           <a:p>
             <a:fld id="{75A9CF98-CC55-774D-9AE2-4D7D2CE05F38}" type="datetimeFigureOut">
               <a:rPr lang="en-US" smtClean="0"/>
-              <a:t>9/8/25</a:t>
+              <a:t>9/9/25</a:t>
             </a:fld>
             <a:endParaRPr lang="en-US"/>
           </a:p>
@@ -868,7 +869,7 @@
           <a:p>
             <a:fld id="{75A9CF98-CC55-774D-9AE2-4D7D2CE05F38}" type="datetimeFigureOut">
               <a:rPr lang="en-US" smtClean="0"/>
-              <a:t>9/8/25</a:t>
+              <a:t>9/9/25</a:t>
             </a:fld>
             <a:endParaRPr lang="en-US"/>
           </a:p>
@@ -1143,7 +1144,7 @@
           <a:p>
             <a:fld id="{75A9CF98-CC55-774D-9AE2-4D7D2CE05F38}" type="datetimeFigureOut">
               <a:rPr lang="en-US" smtClean="0"/>
-              <a:t>9/8/25</a:t>
+              <a:t>9/9/25</a:t>
             </a:fld>
             <a:endParaRPr lang="en-US"/>
           </a:p>
@@ -1408,7 +1409,7 @@
           <a:p>
             <a:fld id="{75A9CF98-CC55-774D-9AE2-4D7D2CE05F38}" type="datetimeFigureOut">
               <a:rPr lang="en-US" smtClean="0"/>
-              <a:t>9/8/25</a:t>
+              <a:t>9/9/25</a:t>
             </a:fld>
             <a:endParaRPr lang="en-US"/>
           </a:p>
@@ -1820,7 +1821,7 @@
           <a:p>
             <a:fld id="{75A9CF98-CC55-774D-9AE2-4D7D2CE05F38}" type="datetimeFigureOut">
               <a:rPr lang="en-US" smtClean="0"/>
-              <a:t>9/8/25</a:t>
+              <a:t>9/9/25</a:t>
             </a:fld>
             <a:endParaRPr lang="en-US"/>
           </a:p>
@@ -1961,7 +1962,7 @@
           <a:p>
             <a:fld id="{75A9CF98-CC55-774D-9AE2-4D7D2CE05F38}" type="datetimeFigureOut">
               <a:rPr lang="en-US" smtClean="0"/>
-              <a:t>9/8/25</a:t>
+              <a:t>9/9/25</a:t>
             </a:fld>
             <a:endParaRPr lang="en-US"/>
           </a:p>
@@ -2074,7 +2075,7 @@
           <a:p>
             <a:fld id="{75A9CF98-CC55-774D-9AE2-4D7D2CE05F38}" type="datetimeFigureOut">
               <a:rPr lang="en-US" smtClean="0"/>
-              <a:t>9/8/25</a:t>
+              <a:t>9/9/25</a:t>
             </a:fld>
             <a:endParaRPr lang="en-US"/>
           </a:p>
@@ -2385,7 +2386,7 @@
           <a:p>
             <a:fld id="{75A9CF98-CC55-774D-9AE2-4D7D2CE05F38}" type="datetimeFigureOut">
               <a:rPr lang="en-US" smtClean="0"/>
-              <a:t>9/8/25</a:t>
+              <a:t>9/9/25</a:t>
             </a:fld>
             <a:endParaRPr lang="en-US"/>
           </a:p>
@@ -2673,7 +2674,7 @@
           <a:p>
             <a:fld id="{75A9CF98-CC55-774D-9AE2-4D7D2CE05F38}" type="datetimeFigureOut">
               <a:rPr lang="en-US" smtClean="0"/>
-              <a:t>9/8/25</a:t>
+              <a:t>9/9/25</a:t>
             </a:fld>
             <a:endParaRPr lang="en-US"/>
           </a:p>
@@ -2914,7 +2915,7 @@
           <a:p>
             <a:fld id="{75A9CF98-CC55-774D-9AE2-4D7D2CE05F38}" type="datetimeFigureOut">
               <a:rPr lang="en-US" smtClean="0"/>
-              <a:t>9/8/25</a:t>
+              <a:t>9/9/25</a:t>
             </a:fld>
             <a:endParaRPr lang="en-US"/>
           </a:p>
@@ -8662,6 +8663,252 @@
         <p:cNvPr id="1" name="">
           <a:extLst>
             <a:ext uri="{FF2B5EF4-FFF2-40B4-BE49-F238E27FC236}">
+              <a16:creationId xmlns:a16="http://schemas.microsoft.com/office/drawing/2014/main" id="{D31DA676-BC81-FE4B-0909-3AC912A5F9A8}"/>
+            </a:ext>
+          </a:extLst>
+        </p:cNvPr>
+        <p:cNvGrpSpPr/>
+        <p:nvPr/>
+      </p:nvGrpSpPr>
+      <p:grpSpPr>
+        <a:xfrm>
+          <a:off x="0" y="0"/>
+          <a:ext cx="0" cy="0"/>
+          <a:chOff x="0" y="0"/>
+          <a:chExt cx="0" cy="0"/>
+        </a:xfrm>
+      </p:grpSpPr>
+      <p:pic>
+        <p:nvPicPr>
+          <p:cNvPr id="15" name="Picture 14">
+            <a:extLst>
+              <a:ext uri="{FF2B5EF4-FFF2-40B4-BE49-F238E27FC236}">
+                <a16:creationId xmlns:a16="http://schemas.microsoft.com/office/drawing/2014/main" id="{CA21A4DF-2FD2-2536-3AD6-3FC70E6011CD}"/>
+              </a:ext>
+            </a:extLst>
+          </p:cNvPr>
+          <p:cNvPicPr>
+            <a:picLocks noChangeAspect="1"/>
+          </p:cNvPicPr>
+          <p:nvPr/>
+        </p:nvPicPr>
+        <p:blipFill>
+          <a:blip r:embed="rId2"/>
+          <a:stretch>
+            <a:fillRect/>
+          </a:stretch>
+        </p:blipFill>
+        <p:spPr>
+          <a:xfrm>
+            <a:off x="2545492" y="4611031"/>
+            <a:ext cx="4493938" cy="2246969"/>
+          </a:xfrm>
+          <a:prstGeom prst="rect">
+            <a:avLst/>
+          </a:prstGeom>
+        </p:spPr>
+      </p:pic>
+      <p:pic>
+        <p:nvPicPr>
+          <p:cNvPr id="7" name="Picture 6">
+            <a:extLst>
+              <a:ext uri="{FF2B5EF4-FFF2-40B4-BE49-F238E27FC236}">
+                <a16:creationId xmlns:a16="http://schemas.microsoft.com/office/drawing/2014/main" id="{930F7D46-E8B9-8B38-B113-97E201573CC2}"/>
+              </a:ext>
+            </a:extLst>
+          </p:cNvPr>
+          <p:cNvPicPr>
+            <a:picLocks noChangeAspect="1"/>
+          </p:cNvPicPr>
+          <p:nvPr/>
+        </p:nvPicPr>
+        <p:blipFill>
+          <a:blip r:embed="rId3"/>
+          <a:stretch>
+            <a:fillRect/>
+          </a:stretch>
+        </p:blipFill>
+        <p:spPr>
+          <a:xfrm>
+            <a:off x="2545492" y="290440"/>
+            <a:ext cx="4493937" cy="2246969"/>
+          </a:xfrm>
+          <a:prstGeom prst="rect">
+            <a:avLst/>
+          </a:prstGeom>
+        </p:spPr>
+      </p:pic>
+      <p:pic>
+        <p:nvPicPr>
+          <p:cNvPr id="9" name="Picture 8">
+            <a:extLst>
+              <a:ext uri="{FF2B5EF4-FFF2-40B4-BE49-F238E27FC236}">
+                <a16:creationId xmlns:a16="http://schemas.microsoft.com/office/drawing/2014/main" id="{84392866-86A5-2DC9-74F1-367B16EDCD46}"/>
+              </a:ext>
+            </a:extLst>
+          </p:cNvPr>
+          <p:cNvPicPr>
+            <a:picLocks noChangeAspect="1"/>
+          </p:cNvPicPr>
+          <p:nvPr/>
+        </p:nvPicPr>
+        <p:blipFill>
+          <a:blip r:embed="rId4"/>
+          <a:stretch>
+            <a:fillRect/>
+          </a:stretch>
+        </p:blipFill>
+        <p:spPr>
+          <a:xfrm>
+            <a:off x="2545492" y="2480236"/>
+            <a:ext cx="4493938" cy="2246969"/>
+          </a:xfrm>
+          <a:prstGeom prst="rect">
+            <a:avLst/>
+          </a:prstGeom>
+        </p:spPr>
+      </p:pic>
+      <p:sp>
+        <p:nvSpPr>
+          <p:cNvPr id="6" name="TextBox 5">
+            <a:extLst>
+              <a:ext uri="{FF2B5EF4-FFF2-40B4-BE49-F238E27FC236}">
+                <a16:creationId xmlns:a16="http://schemas.microsoft.com/office/drawing/2014/main" id="{591473C1-A6F8-5822-32F1-C708156808BD}"/>
+              </a:ext>
+            </a:extLst>
+          </p:cNvPr>
+          <p:cNvSpPr txBox="1"/>
+          <p:nvPr/>
+        </p:nvSpPr>
+        <p:spPr>
+          <a:xfrm>
+            <a:off x="2534657" y="290440"/>
+            <a:ext cx="1013798" cy="261610"/>
+          </a:xfrm>
+          <a:prstGeom prst="rect">
+            <a:avLst/>
+          </a:prstGeom>
+          <a:noFill/>
+        </p:spPr>
+        <p:txBody>
+          <a:bodyPr wrap="square" rtlCol="0">
+            <a:spAutoFit/>
+          </a:bodyPr>
+          <a:lstStyle/>
+          <a:p>
+            <a:r>
+              <a:rPr lang="en-US" sz="1100" b="1" dirty="0"/>
+              <a:t>a) </a:t>
+            </a:r>
+            <a:r>
+              <a:rPr lang="en-US" sz="1100" dirty="0" err="1"/>
+              <a:t>SINDy</a:t>
+            </a:r>
+            <a:endParaRPr lang="en-US" sz="1100" b="1" dirty="0"/>
+          </a:p>
+        </p:txBody>
+      </p:sp>
+      <p:sp>
+        <p:nvSpPr>
+          <p:cNvPr id="11" name="TextBox 10">
+            <a:extLst>
+              <a:ext uri="{FF2B5EF4-FFF2-40B4-BE49-F238E27FC236}">
+                <a16:creationId xmlns:a16="http://schemas.microsoft.com/office/drawing/2014/main" id="{3EE761BB-86A8-C807-07EE-CDC9C356C9A8}"/>
+              </a:ext>
+            </a:extLst>
+          </p:cNvPr>
+          <p:cNvSpPr txBox="1"/>
+          <p:nvPr/>
+        </p:nvSpPr>
+        <p:spPr>
+          <a:xfrm>
+            <a:off x="2457473" y="2486139"/>
+            <a:ext cx="1240060" cy="261610"/>
+          </a:xfrm>
+          <a:prstGeom prst="rect">
+            <a:avLst/>
+          </a:prstGeom>
+          <a:noFill/>
+        </p:spPr>
+        <p:txBody>
+          <a:bodyPr wrap="square" rtlCol="0">
+            <a:spAutoFit/>
+          </a:bodyPr>
+          <a:lstStyle/>
+          <a:p>
+            <a:r>
+              <a:rPr lang="en-US" sz="1100" b="1" dirty="0"/>
+              <a:t>b) </a:t>
+            </a:r>
+            <a:r>
+              <a:rPr lang="en-US" sz="1100" dirty="0"/>
+              <a:t>NN-driven</a:t>
+            </a:r>
+            <a:endParaRPr lang="en-US" sz="1100" b="1" dirty="0"/>
+          </a:p>
+        </p:txBody>
+      </p:sp>
+      <p:sp>
+        <p:nvSpPr>
+          <p:cNvPr id="14" name="TextBox 13">
+            <a:extLst>
+              <a:ext uri="{FF2B5EF4-FFF2-40B4-BE49-F238E27FC236}">
+                <a16:creationId xmlns:a16="http://schemas.microsoft.com/office/drawing/2014/main" id="{58E0F855-0807-2C78-F577-3E9A635BFC79}"/>
+              </a:ext>
+            </a:extLst>
+          </p:cNvPr>
+          <p:cNvSpPr txBox="1"/>
+          <p:nvPr/>
+        </p:nvSpPr>
+        <p:spPr>
+          <a:xfrm>
+            <a:off x="2545492" y="4596400"/>
+            <a:ext cx="841709" cy="261610"/>
+          </a:xfrm>
+          <a:prstGeom prst="rect">
+            <a:avLst/>
+          </a:prstGeom>
+          <a:noFill/>
+        </p:spPr>
+        <p:txBody>
+          <a:bodyPr wrap="square" rtlCol="0">
+            <a:spAutoFit/>
+          </a:bodyPr>
+          <a:lstStyle/>
+          <a:p>
+            <a:r>
+              <a:rPr lang="en-US" sz="1100" b="1" dirty="0"/>
+              <a:t>c) </a:t>
+            </a:r>
+            <a:r>
+              <a:rPr lang="en-US" sz="1100" dirty="0"/>
+              <a:t>AR</a:t>
+            </a:r>
+            <a:endParaRPr lang="en-US" sz="1100" b="1" dirty="0"/>
+          </a:p>
+        </p:txBody>
+      </p:sp>
+    </p:spTree>
+    <p:extLst>
+      <p:ext uri="{BB962C8B-B14F-4D97-AF65-F5344CB8AC3E}">
+        <p14:creationId xmlns:p14="http://schemas.microsoft.com/office/powerpoint/2010/main" val="1765821347"/>
+      </p:ext>
+    </p:extLst>
+  </p:cSld>
+  <p:clrMapOvr>
+    <a:masterClrMapping/>
+  </p:clrMapOvr>
+</p:sld>
+</file>
+
+<file path=ppt/slides/slide7.xml><?xml version="1.0" encoding="utf-8"?>
+<p:sld xmlns:a="http://schemas.openxmlformats.org/drawingml/2006/main" xmlns:r="http://schemas.openxmlformats.org/officeDocument/2006/relationships" xmlns:p="http://schemas.openxmlformats.org/presentationml/2006/main">
+  <p:cSld>
+    <p:spTree>
+      <p:nvGrpSpPr>
+        <p:cNvPr id="1" name="">
+          <a:extLst>
+            <a:ext uri="{FF2B5EF4-FFF2-40B4-BE49-F238E27FC236}">
               <a16:creationId xmlns:a16="http://schemas.microsoft.com/office/drawing/2014/main" id="{22833A9F-1143-B35A-9828-04A5EF283A34}"/>
             </a:ext>
           </a:extLst>

</xml_diff>